<commit_message>
Prezentacja światło: dodane rysunki na slajdach
Co-Authored-By: Claude Sonnet 5.5 <noreply@anthropic.com>
Claude-Session: https://claude.ai/code/session_01RxET8S5NWKo13oo2mh7L1U
</commit_message>
<xml_diff>
--- a/projekty/warsztaty-beauty-product/swiatlo-jako-narzedzie-pracy-poprawiona.pptx
+++ b/projekty/warsztaty-beauty-product/swiatlo-jako-narzedzie-pracy-poprawiona.pptx
@@ -11983,6 +11983,356 @@
 </p:sldLayout>
 </file>
 
+<file path=ppt/slideLayouts/slideLayout21.xml><?xml version="1.0" encoding="utf-8"?>
+<p:sldLayout xmlns:a="http://schemas.openxmlformats.org/drawingml/2006/main" xmlns:r="http://schemas.openxmlformats.org/officeDocument/2006/relationships" xmlns:p="http://schemas.openxmlformats.org/presentationml/2006/main" type="obj" preserve="1">
+  <p:cSld name="Plan spotkania bez grafiki">
+    <p:bg>
+      <p:bgPr>
+        <a:solidFill>
+          <a:schemeClr val="bg1"/>
+        </a:solidFill>
+        <a:effectLst/>
+      </p:bgPr>
+    </p:bg>
+    <p:spTree>
+      <p:nvGrpSpPr>
+        <p:cNvPr id="1" name=""/>
+        <p:cNvGrpSpPr/>
+        <p:nvPr/>
+      </p:nvGrpSpPr>
+      <p:grpSpPr>
+        <a:xfrm>
+          <a:off x="0" y="0"/>
+          <a:ext cx="0" cy="0"/>
+          <a:chOff x="0" y="0"/>
+          <a:chExt cx="0" cy="0"/>
+        </a:xfrm>
+      </p:grpSpPr>
+      <p:sp>
+        <p:nvSpPr>
+          <p:cNvPr id="2" name="Tytuł 1">
+            <a:extLst>
+              <a:ext uri="{FF2B5EF4-FFF2-40B4-BE49-F238E27FC236}">
+                <a16:creationId xmlns:a16="http://schemas.microsoft.com/office/drawing/2014/main" id="{3F0A9B92-C2D0-466A-A680-A35832C452B3}"/>
+              </a:ext>
+            </a:extLst>
+          </p:cNvPr>
+          <p:cNvSpPr>
+            <a:spLocks noGrp="1"/>
+          </p:cNvSpPr>
+          <p:nvPr>
+            <p:ph type="title" hasCustomPrompt="1"/>
+          </p:nvPr>
+        </p:nvSpPr>
+        <p:spPr>
+          <a:xfrm>
+            <a:off x="1333499" y="1020445"/>
+            <a:ext cx="4000000" cy="1325563"/>
+          </a:xfrm>
+        </p:spPr>
+        <p:txBody>
+          <a:bodyPr rtlCol="0" anchor="b">
+            <a:normAutofit/>
+          </a:bodyPr>
+          <a:lstStyle>
+            <a:lvl1pPr>
+              <a:defRPr sz="3200" spc="150" baseline="0">
+                <a:solidFill>
+                  <a:schemeClr val="tx1">
+                    <a:lumMod val="75000"/>
+                    <a:lumOff val="25000"/>
+                  </a:schemeClr>
+                </a:solidFill>
+              </a:defRPr>
+            </a:lvl1pPr>
+          </a:lstStyle>
+          <a:p>
+            <a:pPr rtl="0"/>
+            <a:r>
+              <a:rPr lang="pl-PL" noProof="0"/>
+              <a:t>KLIKNIJ, ABY EDYTOWAĆ STYL WZORCA TYTUŁU</a:t>
+            </a:r>
+          </a:p>
+        </p:txBody>
+      </p:sp>
+      <p:sp>
+        <p:nvSpPr>
+          <p:cNvPr id="3" name="Zawartość — symbol zastępczy 2">
+            <a:extLst>
+              <a:ext uri="{FF2B5EF4-FFF2-40B4-BE49-F238E27FC236}">
+                <a16:creationId xmlns:a16="http://schemas.microsoft.com/office/drawing/2014/main" id="{2DA41CE6-5A88-4C5C-B2A4-6A5D2153B16F}"/>
+              </a:ext>
+            </a:extLst>
+          </p:cNvPr>
+          <p:cNvSpPr>
+            <a:spLocks noGrp="1"/>
+          </p:cNvSpPr>
+          <p:nvPr>
+            <p:ph idx="1" hasCustomPrompt="1"/>
+          </p:nvPr>
+        </p:nvSpPr>
+        <p:spPr>
+          <a:xfrm>
+            <a:off x="1333499" y="2924175"/>
+            <a:ext cx="4000000" cy="3700000"/>
+          </a:xfrm>
+        </p:spPr>
+        <p:txBody>
+          <a:bodyPr rtlCol="0">
+            <a:normAutofit/>
+          </a:bodyPr>
+          <a:lstStyle>
+            <a:lvl1pPr marL="0" indent="0">
+              <a:lnSpc>
+                <a:spcPct val="120000"/>
+              </a:lnSpc>
+              <a:spcBef>
+                <a:spcPts val="1000"/>
+              </a:spcBef>
+              <a:buNone/>
+              <a:defRPr sz="2000">
+                <a:solidFill>
+                  <a:schemeClr val="tx1">
+                    <a:lumMod val="75000"/>
+                    <a:lumOff val="25000"/>
+                  </a:schemeClr>
+                </a:solidFill>
+              </a:defRPr>
+            </a:lvl1pPr>
+            <a:lvl2pPr marL="457200" indent="0">
+              <a:lnSpc>
+                <a:spcPct val="120000"/>
+              </a:lnSpc>
+              <a:spcBef>
+                <a:spcPts val="1000"/>
+              </a:spcBef>
+              <a:buNone/>
+              <a:defRPr sz="1400">
+                <a:solidFill>
+                  <a:schemeClr val="tx1">
+                    <a:lumMod val="75000"/>
+                    <a:lumOff val="25000"/>
+                  </a:schemeClr>
+                </a:solidFill>
+              </a:defRPr>
+            </a:lvl2pPr>
+            <a:lvl3pPr marL="914400" indent="0">
+              <a:lnSpc>
+                <a:spcPct val="120000"/>
+              </a:lnSpc>
+              <a:spcBef>
+                <a:spcPts val="1000"/>
+              </a:spcBef>
+              <a:buNone/>
+              <a:defRPr sz="1400">
+                <a:solidFill>
+                  <a:schemeClr val="tx1">
+                    <a:lumMod val="75000"/>
+                    <a:lumOff val="25000"/>
+                  </a:schemeClr>
+                </a:solidFill>
+              </a:defRPr>
+            </a:lvl3pPr>
+            <a:lvl4pPr marL="1371600" indent="0">
+              <a:lnSpc>
+                <a:spcPct val="120000"/>
+              </a:lnSpc>
+              <a:spcBef>
+                <a:spcPts val="1000"/>
+              </a:spcBef>
+              <a:buNone/>
+              <a:defRPr sz="1400">
+                <a:solidFill>
+                  <a:schemeClr val="tx1">
+                    <a:lumMod val="75000"/>
+                    <a:lumOff val="25000"/>
+                  </a:schemeClr>
+                </a:solidFill>
+              </a:defRPr>
+            </a:lvl4pPr>
+            <a:lvl5pPr marL="1828800" indent="0">
+              <a:lnSpc>
+                <a:spcPct val="120000"/>
+              </a:lnSpc>
+              <a:spcBef>
+                <a:spcPts val="1000"/>
+              </a:spcBef>
+              <a:buNone/>
+              <a:defRPr sz="1400">
+                <a:solidFill>
+                  <a:schemeClr val="tx1">
+                    <a:lumMod val="75000"/>
+                    <a:lumOff val="25000"/>
+                  </a:schemeClr>
+                </a:solidFill>
+              </a:defRPr>
+            </a:lvl5pPr>
+          </a:lstStyle>
+          <a:p>
+            <a:pPr lvl="0" rtl="0"/>
+            <a:r>
+              <a:rPr lang="pl-PL" noProof="0"/>
+              <a:t>Kliknij, aby edytować style wzorców tekstu</a:t>
+            </a:r>
+          </a:p>
+          <a:p>
+            <a:pPr lvl="1" rtl="0"/>
+            <a:r>
+              <a:rPr lang="pl-PL" noProof="0"/>
+              <a:t>Drugi poziom</a:t>
+            </a:r>
+          </a:p>
+          <a:p>
+            <a:pPr lvl="2" rtl="0"/>
+            <a:r>
+              <a:rPr lang="pl-PL" noProof="0"/>
+              <a:t>Trzeci poziom</a:t>
+            </a:r>
+          </a:p>
+          <a:p>
+            <a:pPr lvl="3" rtl="0"/>
+            <a:r>
+              <a:rPr lang="pl-PL" noProof="0"/>
+              <a:t>Czwarty poziom</a:t>
+            </a:r>
+          </a:p>
+          <a:p>
+            <a:pPr lvl="4" rtl="0"/>
+            <a:r>
+              <a:rPr lang="pl-PL" noProof="0"/>
+              <a:t>Piąty poziom</a:t>
+            </a:r>
+          </a:p>
+        </p:txBody>
+      </p:sp>
+      <p:sp>
+        <p:nvSpPr>
+          <p:cNvPr id="4" name="Data — symbol zastępczy 3">
+            <a:extLst>
+              <a:ext uri="{FF2B5EF4-FFF2-40B4-BE49-F238E27FC236}">
+                <a16:creationId xmlns:a16="http://schemas.microsoft.com/office/drawing/2014/main" id="{A39F5093-3C53-4152-B8FE-0522E0795269}"/>
+              </a:ext>
+            </a:extLst>
+          </p:cNvPr>
+          <p:cNvSpPr>
+            <a:spLocks noGrp="1"/>
+          </p:cNvSpPr>
+          <p:nvPr>
+            <p:ph type="dt" sz="half" idx="10"/>
+          </p:nvPr>
+        </p:nvSpPr>
+        <p:spPr>
+          <a:xfrm>
+            <a:off x="1333500" y="6356350"/>
+            <a:ext cx="985157" cy="365125"/>
+          </a:xfrm>
+        </p:spPr>
+        <p:txBody>
+          <a:bodyPr rtlCol="0"/>
+          <a:lstStyle>
+            <a:lvl1pPr>
+              <a:defRPr sz="900"/>
+            </a:lvl1pPr>
+          </a:lstStyle>
+          <a:p>
+            <a:pPr rtl="0"/>
+            <a:r>
+              <a:rPr lang="pl-PL" noProof="0"/>
+              <a:t>20XX</a:t>
+            </a:r>
+          </a:p>
+        </p:txBody>
+      </p:sp>
+      <p:sp>
+        <p:nvSpPr>
+          <p:cNvPr id="5" name="Stopka — symbol zastępczy 4">
+            <a:extLst>
+              <a:ext uri="{FF2B5EF4-FFF2-40B4-BE49-F238E27FC236}">
+                <a16:creationId xmlns:a16="http://schemas.microsoft.com/office/drawing/2014/main" id="{7727F11D-8AF8-44D6-A48B-D8C7779B8B08}"/>
+              </a:ext>
+            </a:extLst>
+          </p:cNvPr>
+          <p:cNvSpPr>
+            <a:spLocks noGrp="1"/>
+          </p:cNvSpPr>
+          <p:nvPr>
+            <p:ph type="ftr" sz="quarter" idx="11"/>
+          </p:nvPr>
+        </p:nvSpPr>
+        <p:spPr>
+          <a:xfrm>
+            <a:off x="2669886" y="6356349"/>
+            <a:ext cx="2482842" cy="365125"/>
+          </a:xfrm>
+        </p:spPr>
+        <p:txBody>
+          <a:bodyPr rtlCol="0"/>
+          <a:lstStyle>
+            <a:lvl1pPr>
+              <a:defRPr sz="900"/>
+            </a:lvl1pPr>
+          </a:lstStyle>
+          <a:p>
+            <a:pPr rtl="0"/>
+            <a:r>
+              <a:rPr lang="pl-PL" noProof="0"/>
+              <a:t>Prezentacja</a:t>
+            </a:r>
+          </a:p>
+        </p:txBody>
+      </p:sp>
+      <p:sp>
+        <p:nvSpPr>
+          <p:cNvPr id="6" name="Numer slajdu — symbol zastępczy 5">
+            <a:extLst>
+              <a:ext uri="{FF2B5EF4-FFF2-40B4-BE49-F238E27FC236}">
+                <a16:creationId xmlns:a16="http://schemas.microsoft.com/office/drawing/2014/main" id="{658C0879-6B0F-4AF6-A997-EC61DA8964AE}"/>
+              </a:ext>
+            </a:extLst>
+          </p:cNvPr>
+          <p:cNvSpPr>
+            <a:spLocks noGrp="1"/>
+          </p:cNvSpPr>
+          <p:nvPr>
+            <p:ph type="sldNum" sz="quarter" idx="12"/>
+          </p:nvPr>
+        </p:nvSpPr>
+        <p:spPr>
+          <a:xfrm>
+            <a:off x="5536305" y="6356350"/>
+            <a:ext cx="987552" cy="365125"/>
+          </a:xfrm>
+        </p:spPr>
+        <p:txBody>
+          <a:bodyPr rtlCol="0"/>
+          <a:lstStyle>
+            <a:lvl1pPr>
+              <a:defRPr sz="900"/>
+            </a:lvl1pPr>
+          </a:lstStyle>
+          <a:p>
+            <a:pPr rtl="0"/>
+            <a:fld id="{B5CEABB6-07DC-46E8-9B57-56EC44A396E5}" type="slidenum">
+              <a:rPr lang="pl-PL" noProof="0" smtClean="0"/>
+              <a:t>‹#›</a:t>
+            </a:fld>
+            <a:endParaRPr lang="pl-PL" noProof="0"/>
+          </a:p>
+        </p:txBody>
+      </p:sp>
+    </p:spTree>
+    <p:extLst>
+      <p:ext uri="{BB962C8B-B14F-4D97-AF65-F5344CB8AC3E}">
+        <p14:creationId xmlns:p14="http://schemas.microsoft.com/office/powerpoint/2010/main" val="2631270364"/>
+      </p:ext>
+    </p:extLst>
+  </p:cSld>
+  <p:clrMapOvr>
+    <a:masterClrMapping/>
+  </p:clrMapOvr>
+</p:sldLayout>
+</file>
+
 <file path=ppt/slideLayouts/slideLayout3.xml><?xml version="1.0" encoding="utf-8"?>
 <p:sldLayout xmlns:a="http://schemas.openxmlformats.org/drawingml/2006/main" xmlns:r="http://schemas.openxmlformats.org/officeDocument/2006/relationships" xmlns:p="http://schemas.openxmlformats.org/presentationml/2006/main" preserve="1">
   <p:cSld name="Oś czasu">
@@ -16649,6 +16999,7 @@
     <p:sldLayoutId id="2147483696" r:id="rId18"/>
     <p:sldLayoutId id="2147483677" r:id="rId19"/>
     <p:sldLayoutId id="2147483678" r:id="rId20"/>
+    <p:sldLayoutId id="2147483750" r:id="rId90"/>
   </p:sldLayoutIdLst>
   <p:hf hdr="0" dt="0"/>
   <p:txStyles>
@@ -17378,6 +17729,266 @@
           </a:p>
         </p:txBody>
       </p:sp>
+      <p:sp>
+        <p:nvSpPr>
+          <p:cNvPr id="101" name="Element 101"/>
+          <p:cNvSpPr/>
+          <p:nvPr/>
+        </p:nvSpPr>
+        <p:spPr>
+          <a:xfrm>
+            <a:off x="6492240" y="2011680"/>
+            <a:ext cx="1463040" cy="1463040"/>
+          </a:xfrm>
+          <a:prstGeom prst="ellipse">
+            <a:avLst/>
+          </a:prstGeom>
+          <a:solidFill>
+            <a:srgbClr val="FFFFFF"/>
+          </a:solidFill>
+          <a:ln w="19050">
+            <a:solidFill>
+              <a:srgbClr val="404040"/>
+            </a:solidFill>
+          </a:ln>
+        </p:spPr>
+        <p:txBody>
+          <a:bodyPr/>
+          <a:lstStyle/>
+          <a:p>
+            <a:endParaRPr lang="pl-PL"/>
+          </a:p>
+        </p:txBody>
+      </p:sp>
+      <p:sp>
+        <p:nvSpPr>
+          <p:cNvPr id="102" name="Element 102"/>
+          <p:cNvSpPr/>
+          <p:nvPr/>
+        </p:nvSpPr>
+        <p:spPr>
+          <a:xfrm>
+            <a:off x="6446520" y="3714750"/>
+            <a:ext cx="2103120" cy="525780"/>
+          </a:xfrm>
+          <a:prstGeom prst="ellipse">
+            <a:avLst/>
+          </a:prstGeom>
+          <a:solidFill>
+            <a:srgbClr val="404040">
+              <a:alpha val="15000"/>
+            </a:srgbClr>
+          </a:solidFill>
+          <a:ln>
+            <a:noFill/>
+          </a:ln>
+        </p:spPr>
+        <p:txBody>
+          <a:bodyPr/>
+          <a:lstStyle/>
+          <a:p>
+            <a:endParaRPr lang="pl-PL"/>
+          </a:p>
+        </p:txBody>
+      </p:sp>
+      <p:sp>
+        <p:nvSpPr>
+          <p:cNvPr id="103" name="Element 103"/>
+          <p:cNvSpPr/>
+          <p:nvPr/>
+        </p:nvSpPr>
+        <p:spPr>
+          <a:xfrm>
+            <a:off x="6629400" y="3760470"/>
+            <a:ext cx="1737360" cy="434340"/>
+          </a:xfrm>
+          <a:prstGeom prst="ellipse">
+            <a:avLst/>
+          </a:prstGeom>
+          <a:solidFill>
+            <a:srgbClr val="404040">
+              <a:alpha val="22000"/>
+            </a:srgbClr>
+          </a:solidFill>
+          <a:ln>
+            <a:noFill/>
+          </a:ln>
+        </p:spPr>
+        <p:txBody>
+          <a:bodyPr/>
+          <a:lstStyle/>
+          <a:p>
+            <a:endParaRPr lang="pl-PL"/>
+          </a:p>
+        </p:txBody>
+      </p:sp>
+      <p:sp>
+        <p:nvSpPr>
+          <p:cNvPr id="104" name="Element 104"/>
+          <p:cNvSpPr/>
+          <p:nvPr/>
+        </p:nvSpPr>
+        <p:spPr>
+          <a:xfrm>
+            <a:off x="6812280" y="3806190"/>
+            <a:ext cx="1371600" cy="342900"/>
+          </a:xfrm>
+          <a:prstGeom prst="ellipse">
+            <a:avLst/>
+          </a:prstGeom>
+          <a:solidFill>
+            <a:srgbClr val="404040">
+              <a:alpha val="35000"/>
+            </a:srgbClr>
+          </a:solidFill>
+          <a:ln>
+            <a:noFill/>
+          </a:ln>
+        </p:spPr>
+        <p:txBody>
+          <a:bodyPr/>
+          <a:lstStyle/>
+          <a:p>
+            <a:endParaRPr lang="pl-PL"/>
+          </a:p>
+        </p:txBody>
+      </p:sp>
+      <p:sp>
+        <p:nvSpPr>
+          <p:cNvPr id="105" name="Element 105"/>
+          <p:cNvSpPr/>
+          <p:nvPr/>
+        </p:nvSpPr>
+        <p:spPr>
+          <a:xfrm>
+            <a:off x="6126480" y="4663440"/>
+            <a:ext cx="2194560" cy="457200"/>
+          </a:xfrm>
+          <a:prstGeom prst="rect">
+            <a:avLst/>
+          </a:prstGeom>
+          <a:noFill/>
+          <a:ln>
+            <a:noFill/>
+          </a:ln>
+        </p:spPr>
+        <p:txBody>
+          <a:bodyPr wrap="square" lIns="0" tIns="0" rIns="0" bIns="0" anchor="ctr">
+            <a:noAutofit/>
+          </a:bodyPr>
+          <a:lstStyle/>
+          <a:p>
+            <a:pPr algn="ctr"/>
+            <a:r>
+              <a:rPr lang="pl-PL" sz="2000" b="1" dirty="0">
+                <a:solidFill>
+                  <a:srgbClr val="404040"/>
+                </a:solidFill>
+                <a:latin typeface="+mn-lt"/>
+              </a:rPr>
+              <a:t>SOFT</a:t>
+            </a:r>
+          </a:p>
+        </p:txBody>
+      </p:sp>
+      <p:sp>
+        <p:nvSpPr>
+          <p:cNvPr id="106" name="Element 106"/>
+          <p:cNvSpPr/>
+          <p:nvPr/>
+        </p:nvSpPr>
+        <p:spPr>
+          <a:xfrm>
+            <a:off x="9326880" y="2011680"/>
+            <a:ext cx="1463040" cy="1463040"/>
+          </a:xfrm>
+          <a:prstGeom prst="ellipse">
+            <a:avLst/>
+          </a:prstGeom>
+          <a:solidFill>
+            <a:srgbClr val="FFFFFF"/>
+          </a:solidFill>
+          <a:ln w="19050">
+            <a:solidFill>
+              <a:srgbClr val="404040"/>
+            </a:solidFill>
+          </a:ln>
+        </p:spPr>
+        <p:txBody>
+          <a:bodyPr/>
+          <a:lstStyle/>
+          <a:p>
+            <a:endParaRPr lang="pl-PL"/>
+          </a:p>
+        </p:txBody>
+      </p:sp>
+      <p:sp>
+        <p:nvSpPr>
+          <p:cNvPr id="107" name="Element 107"/>
+          <p:cNvSpPr/>
+          <p:nvPr/>
+        </p:nvSpPr>
+        <p:spPr>
+          <a:xfrm>
+            <a:off x="9646920" y="3803904"/>
+            <a:ext cx="1371600" cy="347472"/>
+          </a:xfrm>
+          <a:prstGeom prst="ellipse">
+            <a:avLst/>
+          </a:prstGeom>
+          <a:solidFill>
+            <a:srgbClr val="404040"/>
+          </a:solidFill>
+          <a:ln>
+            <a:noFill/>
+          </a:ln>
+        </p:spPr>
+        <p:txBody>
+          <a:bodyPr/>
+          <a:lstStyle/>
+          <a:p>
+            <a:endParaRPr lang="pl-PL"/>
+          </a:p>
+        </p:txBody>
+      </p:sp>
+      <p:sp>
+        <p:nvSpPr>
+          <p:cNvPr id="108" name="Element 108"/>
+          <p:cNvSpPr/>
+          <p:nvPr/>
+        </p:nvSpPr>
+        <p:spPr>
+          <a:xfrm>
+            <a:off x="8961120" y="4663440"/>
+            <a:ext cx="2194560" cy="457200"/>
+          </a:xfrm>
+          <a:prstGeom prst="rect">
+            <a:avLst/>
+          </a:prstGeom>
+          <a:noFill/>
+          <a:ln>
+            <a:noFill/>
+          </a:ln>
+        </p:spPr>
+        <p:txBody>
+          <a:bodyPr wrap="square" lIns="0" tIns="0" rIns="0" bIns="0" anchor="ctr">
+            <a:noAutofit/>
+          </a:bodyPr>
+          <a:lstStyle/>
+          <a:p>
+            <a:pPr algn="ctr"/>
+            <a:r>
+              <a:rPr lang="pl-PL" sz="2000" b="1" dirty="0">
+                <a:solidFill>
+                  <a:srgbClr val="404040"/>
+                </a:solidFill>
+                <a:latin typeface="+mn-lt"/>
+              </a:rPr>
+              <a:t>HARD</a:t>
+            </a:r>
+          </a:p>
+        </p:txBody>
+      </p:sp>
     </p:spTree>
     <p:extLst>
       <p:ext uri="{BB962C8B-B14F-4D97-AF65-F5344CB8AC3E}">
@@ -17879,6 +18490,540 @@
           </a:p>
         </p:txBody>
       </p:sp>
+      <p:cxnSp>
+        <p:nvCxnSpPr>
+          <p:cNvPr id="101" name="Linia 101"/>
+          <p:cNvCxnSpPr/>
+          <p:nvPr/>
+        </p:nvCxnSpPr>
+        <p:spPr>
+          <a:xfrm flipV="1">
+            <a:off x="5852160" y="3291840"/>
+            <a:ext cx="367519" cy="1188720"/>
+          </a:xfrm>
+          <a:prstGeom prst="line">
+            <a:avLst/>
+          </a:prstGeom>
+          <a:ln w="19050">
+            <a:solidFill>
+              <a:srgbClr val="E3B18D"/>
+            </a:solidFill>
+          </a:ln>
+        </p:spPr>
+      </p:cxnSp>
+      <p:cxnSp>
+        <p:nvCxnSpPr>
+          <p:cNvPr id="102" name="Linia 102"/>
+          <p:cNvCxnSpPr/>
+          <p:nvPr/>
+        </p:nvCxnSpPr>
+        <p:spPr>
+          <a:xfrm flipV="1">
+            <a:off x="6219679" y="2421637"/>
+            <a:ext cx="1004081" cy="870203"/>
+          </a:xfrm>
+          <a:prstGeom prst="line">
+            <a:avLst/>
+          </a:prstGeom>
+          <a:ln w="19050">
+            <a:solidFill>
+              <a:srgbClr val="E3B18D"/>
+            </a:solidFill>
+          </a:ln>
+        </p:spPr>
+      </p:cxnSp>
+      <p:cxnSp>
+        <p:nvCxnSpPr>
+          <p:cNvPr id="103" name="Linia 103"/>
+          <p:cNvCxnSpPr/>
+          <p:nvPr/>
+        </p:nvCxnSpPr>
+        <p:spPr>
+          <a:xfrm flipV="1">
+            <a:off x="7223760" y="2103120"/>
+            <a:ext cx="1371600" cy="318517"/>
+          </a:xfrm>
+          <a:prstGeom prst="line">
+            <a:avLst/>
+          </a:prstGeom>
+          <a:ln w="19050">
+            <a:solidFill>
+              <a:srgbClr val="E3B18D"/>
+            </a:solidFill>
+          </a:ln>
+        </p:spPr>
+      </p:cxnSp>
+      <p:cxnSp>
+        <p:nvCxnSpPr>
+          <p:cNvPr id="104" name="Linia 104"/>
+          <p:cNvCxnSpPr/>
+          <p:nvPr/>
+        </p:nvCxnSpPr>
+        <p:spPr>
+          <a:xfrm>
+            <a:off x="8595360" y="2103120"/>
+            <a:ext cx="1371600" cy="318517"/>
+          </a:xfrm>
+          <a:prstGeom prst="line">
+            <a:avLst/>
+          </a:prstGeom>
+          <a:ln w="19050">
+            <a:solidFill>
+              <a:srgbClr val="E3B18D"/>
+            </a:solidFill>
+          </a:ln>
+        </p:spPr>
+      </p:cxnSp>
+      <p:cxnSp>
+        <p:nvCxnSpPr>
+          <p:cNvPr id="105" name="Linia 105"/>
+          <p:cNvCxnSpPr/>
+          <p:nvPr/>
+        </p:nvCxnSpPr>
+        <p:spPr>
+          <a:xfrm>
+            <a:off x="9966960" y="2421637"/>
+            <a:ext cx="1004081" cy="870203"/>
+          </a:xfrm>
+          <a:prstGeom prst="line">
+            <a:avLst/>
+          </a:prstGeom>
+          <a:ln w="19050">
+            <a:solidFill>
+              <a:srgbClr val="E3B18D"/>
+            </a:solidFill>
+          </a:ln>
+        </p:spPr>
+      </p:cxnSp>
+      <p:cxnSp>
+        <p:nvCxnSpPr>
+          <p:cNvPr id="106" name="Linia 106"/>
+          <p:cNvCxnSpPr/>
+          <p:nvPr/>
+        </p:nvCxnSpPr>
+        <p:spPr>
+          <a:xfrm>
+            <a:off x="10971041" y="3291840"/>
+            <a:ext cx="367519" cy="1188720"/>
+          </a:xfrm>
+          <a:prstGeom prst="line">
+            <a:avLst/>
+          </a:prstGeom>
+          <a:ln w="19050">
+            <a:solidFill>
+              <a:srgbClr val="E3B18D"/>
+            </a:solidFill>
+          </a:ln>
+        </p:spPr>
+      </p:cxnSp>
+      <p:sp>
+        <p:nvSpPr>
+          <p:cNvPr id="107" name="Element 107"/>
+          <p:cNvSpPr/>
+          <p:nvPr/>
+        </p:nvSpPr>
+        <p:spPr>
+          <a:xfrm>
+            <a:off x="5577840" y="4206240"/>
+            <a:ext cx="548640" cy="548640"/>
+          </a:xfrm>
+          <a:prstGeom prst="ellipse">
+            <a:avLst/>
+          </a:prstGeom>
+          <a:solidFill>
+            <a:srgbClr val="FFFFFF"/>
+          </a:solidFill>
+          <a:ln w="19050">
+            <a:solidFill>
+              <a:srgbClr val="E3B18D"/>
+            </a:solidFill>
+          </a:ln>
+        </p:spPr>
+        <p:txBody>
+          <a:bodyPr wrap="square" lIns="0" tIns="0" rIns="0" bIns="0" anchor="ctr">
+            <a:noAutofit/>
+          </a:bodyPr>
+          <a:lstStyle/>
+          <a:p>
+            <a:pPr algn="ctr"/>
+            <a:r>
+              <a:rPr lang="pl-PL" sz="1600" b="1" dirty="0">
+                <a:solidFill>
+                  <a:srgbClr val="404040"/>
+                </a:solidFill>
+                <a:latin typeface="+mn-lt"/>
+              </a:rPr>
+              <a:t>1</a:t>
+            </a:r>
+          </a:p>
+        </p:txBody>
+      </p:sp>
+      <p:sp>
+        <p:nvSpPr>
+          <p:cNvPr id="108" name="Element 108"/>
+          <p:cNvSpPr/>
+          <p:nvPr/>
+        </p:nvSpPr>
+        <p:spPr>
+          <a:xfrm>
+            <a:off x="5945359" y="3017520"/>
+            <a:ext cx="548640" cy="548640"/>
+          </a:xfrm>
+          <a:prstGeom prst="ellipse">
+            <a:avLst/>
+          </a:prstGeom>
+          <a:solidFill>
+            <a:srgbClr val="FFFFFF"/>
+          </a:solidFill>
+          <a:ln w="19050">
+            <a:solidFill>
+              <a:srgbClr val="E3B18D"/>
+            </a:solidFill>
+          </a:ln>
+        </p:spPr>
+        <p:txBody>
+          <a:bodyPr wrap="square" lIns="0" tIns="0" rIns="0" bIns="0" anchor="ctr">
+            <a:noAutofit/>
+          </a:bodyPr>
+          <a:lstStyle/>
+          <a:p>
+            <a:pPr algn="ctr"/>
+            <a:r>
+              <a:rPr lang="pl-PL" sz="1600" b="1" dirty="0">
+                <a:solidFill>
+                  <a:srgbClr val="404040"/>
+                </a:solidFill>
+                <a:latin typeface="+mn-lt"/>
+              </a:rPr>
+              <a:t>2</a:t>
+            </a:r>
+          </a:p>
+        </p:txBody>
+      </p:sp>
+      <p:sp>
+        <p:nvSpPr>
+          <p:cNvPr id="109" name="Element 109"/>
+          <p:cNvSpPr/>
+          <p:nvPr/>
+        </p:nvSpPr>
+        <p:spPr>
+          <a:xfrm>
+            <a:off x="6949440" y="2147317"/>
+            <a:ext cx="548640" cy="548640"/>
+          </a:xfrm>
+          <a:prstGeom prst="ellipse">
+            <a:avLst/>
+          </a:prstGeom>
+          <a:solidFill>
+            <a:srgbClr val="FFFFFF"/>
+          </a:solidFill>
+          <a:ln w="19050">
+            <a:solidFill>
+              <a:srgbClr val="E3B18D"/>
+            </a:solidFill>
+          </a:ln>
+        </p:spPr>
+        <p:txBody>
+          <a:bodyPr wrap="square" lIns="0" tIns="0" rIns="0" bIns="0" anchor="ctr">
+            <a:noAutofit/>
+          </a:bodyPr>
+          <a:lstStyle/>
+          <a:p>
+            <a:pPr algn="ctr"/>
+            <a:r>
+              <a:rPr lang="pl-PL" sz="1600" b="1" dirty="0">
+                <a:solidFill>
+                  <a:srgbClr val="404040"/>
+                </a:solidFill>
+                <a:latin typeface="+mn-lt"/>
+              </a:rPr>
+              <a:t>3</a:t>
+            </a:r>
+          </a:p>
+        </p:txBody>
+      </p:sp>
+      <p:sp>
+        <p:nvSpPr>
+          <p:cNvPr id="110" name="Element 110"/>
+          <p:cNvSpPr/>
+          <p:nvPr/>
+        </p:nvSpPr>
+        <p:spPr>
+          <a:xfrm>
+            <a:off x="8321040" y="1828800"/>
+            <a:ext cx="548640" cy="548640"/>
+          </a:xfrm>
+          <a:prstGeom prst="ellipse">
+            <a:avLst/>
+          </a:prstGeom>
+          <a:solidFill>
+            <a:srgbClr val="FFFFFF"/>
+          </a:solidFill>
+          <a:ln w="19050">
+            <a:solidFill>
+              <a:srgbClr val="E3B18D"/>
+            </a:solidFill>
+          </a:ln>
+        </p:spPr>
+        <p:txBody>
+          <a:bodyPr wrap="square" lIns="0" tIns="0" rIns="0" bIns="0" anchor="ctr">
+            <a:noAutofit/>
+          </a:bodyPr>
+          <a:lstStyle/>
+          <a:p>
+            <a:pPr algn="ctr"/>
+            <a:r>
+              <a:rPr lang="pl-PL" sz="1600" b="1" dirty="0">
+                <a:solidFill>
+                  <a:srgbClr val="404040"/>
+                </a:solidFill>
+                <a:latin typeface="+mn-lt"/>
+              </a:rPr>
+              <a:t>4</a:t>
+            </a:r>
+          </a:p>
+        </p:txBody>
+      </p:sp>
+      <p:sp>
+        <p:nvSpPr>
+          <p:cNvPr id="111" name="Element 111"/>
+          <p:cNvSpPr/>
+          <p:nvPr/>
+        </p:nvSpPr>
+        <p:spPr>
+          <a:xfrm>
+            <a:off x="9692640" y="2147317"/>
+            <a:ext cx="548640" cy="548640"/>
+          </a:xfrm>
+          <a:prstGeom prst="ellipse">
+            <a:avLst/>
+          </a:prstGeom>
+          <a:solidFill>
+            <a:srgbClr val="FFFFFF"/>
+          </a:solidFill>
+          <a:ln w="19050">
+            <a:solidFill>
+              <a:srgbClr val="E3B18D"/>
+            </a:solidFill>
+          </a:ln>
+        </p:spPr>
+        <p:txBody>
+          <a:bodyPr wrap="square" lIns="0" tIns="0" rIns="0" bIns="0" anchor="ctr">
+            <a:noAutofit/>
+          </a:bodyPr>
+          <a:lstStyle/>
+          <a:p>
+            <a:pPr algn="ctr"/>
+            <a:r>
+              <a:rPr lang="pl-PL" sz="1600" b="1" dirty="0">
+                <a:solidFill>
+                  <a:srgbClr val="404040"/>
+                </a:solidFill>
+                <a:latin typeface="+mn-lt"/>
+              </a:rPr>
+              <a:t>5</a:t>
+            </a:r>
+          </a:p>
+        </p:txBody>
+      </p:sp>
+      <p:sp>
+        <p:nvSpPr>
+          <p:cNvPr id="112" name="Element 112"/>
+          <p:cNvSpPr/>
+          <p:nvPr/>
+        </p:nvSpPr>
+        <p:spPr>
+          <a:xfrm>
+            <a:off x="10696721" y="3017520"/>
+            <a:ext cx="548640" cy="548640"/>
+          </a:xfrm>
+          <a:prstGeom prst="ellipse">
+            <a:avLst/>
+          </a:prstGeom>
+          <a:solidFill>
+            <a:srgbClr val="FFFFFF"/>
+          </a:solidFill>
+          <a:ln w="19050">
+            <a:solidFill>
+              <a:srgbClr val="E3B18D"/>
+            </a:solidFill>
+          </a:ln>
+        </p:spPr>
+        <p:txBody>
+          <a:bodyPr wrap="square" lIns="0" tIns="0" rIns="0" bIns="0" anchor="ctr">
+            <a:noAutofit/>
+          </a:bodyPr>
+          <a:lstStyle/>
+          <a:p>
+            <a:pPr algn="ctr"/>
+            <a:r>
+              <a:rPr lang="pl-PL" sz="1600" b="1" dirty="0">
+                <a:solidFill>
+                  <a:srgbClr val="404040"/>
+                </a:solidFill>
+                <a:latin typeface="+mn-lt"/>
+              </a:rPr>
+              <a:t>6</a:t>
+            </a:r>
+          </a:p>
+        </p:txBody>
+      </p:sp>
+      <p:sp>
+        <p:nvSpPr>
+          <p:cNvPr id="113" name="Element 113"/>
+          <p:cNvSpPr/>
+          <p:nvPr/>
+        </p:nvSpPr>
+        <p:spPr>
+          <a:xfrm>
+            <a:off x="11064240" y="4206240"/>
+            <a:ext cx="548640" cy="548640"/>
+          </a:xfrm>
+          <a:prstGeom prst="ellipse">
+            <a:avLst/>
+          </a:prstGeom>
+          <a:solidFill>
+            <a:srgbClr val="FFFFFF"/>
+          </a:solidFill>
+          <a:ln w="19050">
+            <a:solidFill>
+              <a:srgbClr val="E3B18D"/>
+            </a:solidFill>
+          </a:ln>
+        </p:spPr>
+        <p:txBody>
+          <a:bodyPr wrap="square" lIns="0" tIns="0" rIns="0" bIns="0" anchor="ctr">
+            <a:noAutofit/>
+          </a:bodyPr>
+          <a:lstStyle/>
+          <a:p>
+            <a:pPr algn="ctr"/>
+            <a:r>
+              <a:rPr lang="pl-PL" sz="1600" b="1" dirty="0">
+                <a:solidFill>
+                  <a:srgbClr val="404040"/>
+                </a:solidFill>
+                <a:latin typeface="+mn-lt"/>
+              </a:rPr>
+              <a:t>7</a:t>
+            </a:r>
+          </a:p>
+        </p:txBody>
+      </p:sp>
+      <p:sp>
+        <p:nvSpPr>
+          <p:cNvPr id="114" name="Element 114"/>
+          <p:cNvSpPr/>
+          <p:nvPr/>
+        </p:nvSpPr>
+        <p:spPr>
+          <a:xfrm>
+            <a:off x="5394960" y="4983480"/>
+            <a:ext cx="1280160" cy="365760"/>
+          </a:xfrm>
+          <a:prstGeom prst="rect">
+            <a:avLst/>
+          </a:prstGeom>
+          <a:noFill/>
+          <a:ln>
+            <a:noFill/>
+          </a:ln>
+        </p:spPr>
+        <p:txBody>
+          <a:bodyPr wrap="square" lIns="0" tIns="0" rIns="0" bIns="0" anchor="ctr">
+            <a:noAutofit/>
+          </a:bodyPr>
+          <a:lstStyle/>
+          <a:p>
+            <a:pPr algn="ctr"/>
+            <a:r>
+              <a:rPr lang="pl-PL" sz="1600" b="0" dirty="0">
+                <a:solidFill>
+                  <a:srgbClr val="8A8A8A"/>
+                </a:solidFill>
+                <a:latin typeface="+mn-lt"/>
+              </a:rPr>
+              <a:t>9:00</a:t>
+            </a:r>
+          </a:p>
+        </p:txBody>
+      </p:sp>
+      <p:sp>
+        <p:nvSpPr>
+          <p:cNvPr id="115" name="Element 115"/>
+          <p:cNvSpPr/>
+          <p:nvPr/>
+        </p:nvSpPr>
+        <p:spPr>
+          <a:xfrm>
+            <a:off x="10515600" y="4983480"/>
+            <a:ext cx="1280160" cy="365760"/>
+          </a:xfrm>
+          <a:prstGeom prst="rect">
+            <a:avLst/>
+          </a:prstGeom>
+          <a:noFill/>
+          <a:ln>
+            <a:noFill/>
+          </a:ln>
+        </p:spPr>
+        <p:txBody>
+          <a:bodyPr wrap="square" lIns="0" tIns="0" rIns="0" bIns="0" anchor="ctr">
+            <a:noAutofit/>
+          </a:bodyPr>
+          <a:lstStyle/>
+          <a:p>
+            <a:pPr algn="ctr"/>
+            <a:r>
+              <a:rPr lang="pl-PL" sz="1600" b="0" dirty="0">
+                <a:solidFill>
+                  <a:srgbClr val="8A8A8A"/>
+                </a:solidFill>
+                <a:latin typeface="+mn-lt"/>
+              </a:rPr>
+              <a:t>17:50</a:t>
+            </a:r>
+          </a:p>
+        </p:txBody>
+      </p:sp>
+      <p:sp>
+        <p:nvSpPr>
+          <p:cNvPr id="116" name="Element 116"/>
+          <p:cNvSpPr/>
+          <p:nvPr/>
+        </p:nvSpPr>
+        <p:spPr>
+          <a:xfrm>
+            <a:off x="7223760" y="3383280"/>
+            <a:ext cx="2743200" cy="457200"/>
+          </a:xfrm>
+          <a:prstGeom prst="rect">
+            <a:avLst/>
+          </a:prstGeom>
+          <a:noFill/>
+          <a:ln>
+            <a:noFill/>
+          </a:ln>
+        </p:spPr>
+        <p:txBody>
+          <a:bodyPr wrap="square" lIns="0" tIns="0" rIns="0" bIns="0" anchor="ctr">
+            <a:noAutofit/>
+          </a:bodyPr>
+          <a:lstStyle/>
+          <a:p>
+            <a:pPr algn="ctr"/>
+            <a:r>
+              <a:rPr lang="pl-PL" sz="1800" b="0" dirty="0">
+                <a:solidFill>
+                  <a:srgbClr val="8A8A8A"/>
+                </a:solidFill>
+                <a:latin typeface="+mn-lt"/>
+              </a:rPr>
+              <a:t>cały dzień, 7 bloków</a:t>
+            </a:r>
+          </a:p>
+        </p:txBody>
+      </p:sp>
     </p:spTree>
     <p:extLst>
       <p:ext uri="{BB962C8B-B14F-4D97-AF65-F5344CB8AC3E}">
@@ -18217,6 +19362,347 @@
           </a:p>
         </p:txBody>
       </p:sp>
+      <p:cxnSp>
+        <p:nvCxnSpPr>
+          <p:cNvPr id="101" name="Linia 101"/>
+          <p:cNvCxnSpPr/>
+          <p:nvPr/>
+        </p:nvCxnSpPr>
+        <p:spPr>
+          <a:xfrm flipV="1">
+            <a:off x="6309360" y="1417320"/>
+            <a:ext cx="1828800" cy="3337560"/>
+          </a:xfrm>
+          <a:prstGeom prst="line">
+            <a:avLst/>
+          </a:prstGeom>
+          <a:ln w="25400">
+            <a:solidFill>
+              <a:srgbClr val="E3B18D"/>
+            </a:solidFill>
+          </a:ln>
+        </p:spPr>
+      </p:cxnSp>
+      <p:cxnSp>
+        <p:nvCxnSpPr>
+          <p:cNvPr id="102" name="Linia 102"/>
+          <p:cNvCxnSpPr/>
+          <p:nvPr/>
+        </p:nvCxnSpPr>
+        <p:spPr>
+          <a:xfrm>
+            <a:off x="8138160" y="1417320"/>
+            <a:ext cx="1828800" cy="3337560"/>
+          </a:xfrm>
+          <a:prstGeom prst="line">
+            <a:avLst/>
+          </a:prstGeom>
+          <a:ln w="25400">
+            <a:solidFill>
+              <a:srgbClr val="E3B18D"/>
+            </a:solidFill>
+          </a:ln>
+        </p:spPr>
+      </p:cxnSp>
+      <p:cxnSp>
+        <p:nvCxnSpPr>
+          <p:cNvPr id="103" name="Linia 103"/>
+          <p:cNvCxnSpPr/>
+          <p:nvPr/>
+        </p:nvCxnSpPr>
+        <p:spPr>
+          <a:xfrm>
+            <a:off x="6309360" y="4754880"/>
+            <a:ext cx="3657600" cy="0"/>
+          </a:xfrm>
+          <a:prstGeom prst="line">
+            <a:avLst/>
+          </a:prstGeom>
+          <a:ln w="25400">
+            <a:solidFill>
+              <a:srgbClr val="E3B18D"/>
+            </a:solidFill>
+          </a:ln>
+        </p:spPr>
+      </p:cxnSp>
+      <p:sp>
+        <p:nvSpPr>
+          <p:cNvPr id="104" name="Element 104"/>
+          <p:cNvSpPr/>
+          <p:nvPr/>
+        </p:nvSpPr>
+        <p:spPr>
+          <a:xfrm>
+            <a:off x="7635240" y="914400"/>
+            <a:ext cx="1005840" cy="1005840"/>
+          </a:xfrm>
+          <a:prstGeom prst="ellipse">
+            <a:avLst/>
+          </a:prstGeom>
+          <a:solidFill>
+            <a:srgbClr val="FFFFFF"/>
+          </a:solidFill>
+          <a:ln w="19050">
+            <a:solidFill>
+              <a:srgbClr val="404040"/>
+            </a:solidFill>
+          </a:ln>
+        </p:spPr>
+        <p:txBody>
+          <a:bodyPr wrap="square" lIns="0" tIns="0" rIns="0" bIns="0" anchor="ctr">
+            <a:noAutofit/>
+          </a:bodyPr>
+          <a:lstStyle/>
+          <a:p>
+            <a:pPr algn="ctr"/>
+            <a:r>
+              <a:rPr lang="pl-PL" sz="2000" b="1" dirty="0">
+                <a:solidFill>
+                  <a:srgbClr val="404040"/>
+                </a:solidFill>
+                <a:latin typeface="+mn-lt"/>
+              </a:rPr>
+              <a:t>ISO</a:t>
+            </a:r>
+          </a:p>
+        </p:txBody>
+      </p:sp>
+      <p:sp>
+        <p:nvSpPr>
+          <p:cNvPr id="105" name="Element 105"/>
+          <p:cNvSpPr/>
+          <p:nvPr/>
+        </p:nvSpPr>
+        <p:spPr>
+          <a:xfrm>
+            <a:off x="5806440" y="4251960"/>
+            <a:ext cx="1005840" cy="1005840"/>
+          </a:xfrm>
+          <a:prstGeom prst="ellipse">
+            <a:avLst/>
+          </a:prstGeom>
+          <a:solidFill>
+            <a:srgbClr val="FFFFFF"/>
+          </a:solidFill>
+          <a:ln w="19050">
+            <a:solidFill>
+              <a:srgbClr val="404040"/>
+            </a:solidFill>
+          </a:ln>
+        </p:spPr>
+        <p:txBody>
+          <a:bodyPr wrap="square" lIns="0" tIns="0" rIns="0" bIns="0" anchor="ctr">
+            <a:noAutofit/>
+          </a:bodyPr>
+          <a:lstStyle/>
+          <a:p>
+            <a:pPr algn="ctr"/>
+            <a:r>
+              <a:rPr lang="pl-PL" sz="2000" b="1" dirty="0">
+                <a:solidFill>
+                  <a:srgbClr val="404040"/>
+                </a:solidFill>
+                <a:latin typeface="+mn-lt"/>
+              </a:rPr>
+              <a:t>f/</a:t>
+            </a:r>
+          </a:p>
+        </p:txBody>
+      </p:sp>
+      <p:sp>
+        <p:nvSpPr>
+          <p:cNvPr id="106" name="Element 106"/>
+          <p:cNvSpPr/>
+          <p:nvPr/>
+        </p:nvSpPr>
+        <p:spPr>
+          <a:xfrm>
+            <a:off x="9464040" y="4251960"/>
+            <a:ext cx="1005840" cy="1005840"/>
+          </a:xfrm>
+          <a:prstGeom prst="ellipse">
+            <a:avLst/>
+          </a:prstGeom>
+          <a:solidFill>
+            <a:srgbClr val="FFFFFF"/>
+          </a:solidFill>
+          <a:ln w="19050">
+            <a:solidFill>
+              <a:srgbClr val="404040"/>
+            </a:solidFill>
+          </a:ln>
+        </p:spPr>
+        <p:txBody>
+          <a:bodyPr wrap="square" lIns="0" tIns="0" rIns="0" bIns="0" anchor="ctr">
+            <a:noAutofit/>
+          </a:bodyPr>
+          <a:lstStyle/>
+          <a:p>
+            <a:pPr algn="ctr"/>
+            <a:r>
+              <a:rPr lang="pl-PL" sz="2000" b="1" dirty="0">
+                <a:solidFill>
+                  <a:srgbClr val="404040"/>
+                </a:solidFill>
+                <a:latin typeface="+mn-lt"/>
+              </a:rPr>
+              <a:t>1/s</a:t>
+            </a:r>
+          </a:p>
+        </p:txBody>
+      </p:sp>
+      <p:sp>
+        <p:nvSpPr>
+          <p:cNvPr id="107" name="Element 107"/>
+          <p:cNvSpPr/>
+          <p:nvPr/>
+        </p:nvSpPr>
+        <p:spPr>
+          <a:xfrm>
+            <a:off x="7223760" y="3749040"/>
+            <a:ext cx="1828800" cy="365760"/>
+          </a:xfrm>
+          <a:prstGeom prst="rect">
+            <a:avLst/>
+          </a:prstGeom>
+          <a:noFill/>
+          <a:ln>
+            <a:noFill/>
+          </a:ln>
+        </p:spPr>
+        <p:txBody>
+          <a:bodyPr wrap="square" lIns="0" tIns="0" rIns="0" bIns="0" anchor="ctr">
+            <a:noAutofit/>
+          </a:bodyPr>
+          <a:lstStyle/>
+          <a:p>
+            <a:pPr algn="ctr"/>
+            <a:r>
+              <a:rPr lang="pl-PL" sz="1600" b="1" dirty="0">
+                <a:solidFill>
+                  <a:srgbClr val="8A8A8A"/>
+                </a:solidFill>
+                <a:latin typeface="+mn-lt"/>
+              </a:rPr>
+              <a:t>EKSPOZYCJA</a:t>
+            </a:r>
+          </a:p>
+        </p:txBody>
+      </p:sp>
+      <p:sp>
+        <p:nvSpPr>
+          <p:cNvPr id="108" name="Element 108"/>
+          <p:cNvSpPr/>
+          <p:nvPr/>
+        </p:nvSpPr>
+        <p:spPr>
+          <a:xfrm>
+            <a:off x="8823960" y="1234440"/>
+            <a:ext cx="2011680" cy="365760"/>
+          </a:xfrm>
+          <a:prstGeom prst="rect">
+            <a:avLst/>
+          </a:prstGeom>
+          <a:noFill/>
+          <a:ln>
+            <a:noFill/>
+          </a:ln>
+        </p:spPr>
+        <p:txBody>
+          <a:bodyPr wrap="square" lIns="0" tIns="0" rIns="0" bIns="0" anchor="ctr">
+            <a:noAutofit/>
+          </a:bodyPr>
+          <a:lstStyle/>
+          <a:p>
+            <a:pPr algn="l"/>
+            <a:r>
+              <a:rPr lang="pl-PL" sz="1600" b="0" dirty="0">
+                <a:solidFill>
+                  <a:srgbClr val="8A8A8A"/>
+                </a:solidFill>
+                <a:latin typeface="+mn-lt"/>
+              </a:rPr>
+              <a:t>czułość</a:t>
+            </a:r>
+          </a:p>
+        </p:txBody>
+      </p:sp>
+      <p:sp>
+        <p:nvSpPr>
+          <p:cNvPr id="109" name="Element 109"/>
+          <p:cNvSpPr/>
+          <p:nvPr/>
+        </p:nvSpPr>
+        <p:spPr>
+          <a:xfrm>
+            <a:off x="5394960" y="5394960"/>
+            <a:ext cx="1828800" cy="365760"/>
+          </a:xfrm>
+          <a:prstGeom prst="rect">
+            <a:avLst/>
+          </a:prstGeom>
+          <a:noFill/>
+          <a:ln>
+            <a:noFill/>
+          </a:ln>
+        </p:spPr>
+        <p:txBody>
+          <a:bodyPr wrap="square" lIns="0" tIns="0" rIns="0" bIns="0" anchor="ctr">
+            <a:noAutofit/>
+          </a:bodyPr>
+          <a:lstStyle/>
+          <a:p>
+            <a:pPr algn="ctr"/>
+            <a:r>
+              <a:rPr lang="pl-PL" sz="1600" b="0" dirty="0">
+                <a:solidFill>
+                  <a:srgbClr val="8A8A8A"/>
+                </a:solidFill>
+                <a:latin typeface="+mn-lt"/>
+              </a:rPr>
+              <a:t>przysłona</a:t>
+            </a:r>
+          </a:p>
+        </p:txBody>
+      </p:sp>
+      <p:sp>
+        <p:nvSpPr>
+          <p:cNvPr id="110" name="Element 110"/>
+          <p:cNvSpPr/>
+          <p:nvPr/>
+        </p:nvSpPr>
+        <p:spPr>
+          <a:xfrm>
+            <a:off x="9052560" y="5394960"/>
+            <a:ext cx="1828800" cy="365760"/>
+          </a:xfrm>
+          <a:prstGeom prst="rect">
+            <a:avLst/>
+          </a:prstGeom>
+          <a:noFill/>
+          <a:ln>
+            <a:noFill/>
+          </a:ln>
+        </p:spPr>
+        <p:txBody>
+          <a:bodyPr wrap="square" lIns="0" tIns="0" rIns="0" bIns="0" anchor="ctr">
+            <a:noAutofit/>
+          </a:bodyPr>
+          <a:lstStyle/>
+          <a:p>
+            <a:pPr algn="ctr"/>
+            <a:r>
+              <a:rPr lang="pl-PL" sz="1600" b="0" dirty="0">
+                <a:solidFill>
+                  <a:srgbClr val="8A8A8A"/>
+                </a:solidFill>
+                <a:latin typeface="+mn-lt"/>
+              </a:rPr>
+              <a:t>migawka</a:t>
+            </a:r>
+          </a:p>
+        </p:txBody>
+      </p:sp>
     </p:spTree>
     <p:extLst>
       <p:ext uri="{BB962C8B-B14F-4D97-AF65-F5344CB8AC3E}">
@@ -18386,6 +19872,233 @@
           </a:p>
         </p:txBody>
       </p:sp>
+      <p:sp>
+        <p:nvSpPr>
+          <p:cNvPr id="101" name="Gradient 101"/>
+          <p:cNvSpPr/>
+          <p:nvPr/>
+        </p:nvSpPr>
+        <p:spPr>
+          <a:xfrm>
+            <a:off x="6126480" y="3017520"/>
+            <a:ext cx="5120640" cy="640080"/>
+          </a:xfrm>
+          <a:prstGeom prst="rect">
+            <a:avLst/>
+          </a:prstGeom>
+          <a:gradFill>
+            <a:gsLst>
+              <a:gs pos="0">
+                <a:srgbClr val="FFB36B"/>
+              </a:gs>
+              <a:gs pos="100000">
+                <a:srgbClr val="CFE0FF"/>
+              </a:gs>
+            </a:gsLst>
+            <a:lin ang="0" scaled="0"/>
+          </a:gradFill>
+          <a:ln>
+            <a:noFill/>
+          </a:ln>
+        </p:spPr>
+        <p:txBody>
+          <a:bodyPr/>
+          <a:lstStyle/>
+          <a:p>
+            <a:endParaRPr lang="pl-PL"/>
+          </a:p>
+        </p:txBody>
+      </p:sp>
+      <p:sp>
+        <p:nvSpPr>
+          <p:cNvPr id="102" name="Element 102"/>
+          <p:cNvSpPr/>
+          <p:nvPr/>
+        </p:nvSpPr>
+        <p:spPr>
+          <a:xfrm>
+            <a:off x="6126480" y="2377440"/>
+            <a:ext cx="2286000" cy="457200"/>
+          </a:xfrm>
+          <a:prstGeom prst="rect">
+            <a:avLst/>
+          </a:prstGeom>
+          <a:noFill/>
+          <a:ln>
+            <a:noFill/>
+          </a:ln>
+        </p:spPr>
+        <p:txBody>
+          <a:bodyPr wrap="square" lIns="0" tIns="0" rIns="0" bIns="0" anchor="ctr">
+            <a:noAutofit/>
+          </a:bodyPr>
+          <a:lstStyle/>
+          <a:p>
+            <a:pPr algn="l"/>
+            <a:r>
+              <a:rPr lang="pl-PL" sz="1800" b="0" dirty="0">
+                <a:solidFill>
+                  <a:srgbClr val="404040"/>
+                </a:solidFill>
+                <a:latin typeface="+mn-lt"/>
+              </a:rPr>
+              <a:t>ciepłe</a:t>
+            </a:r>
+          </a:p>
+        </p:txBody>
+      </p:sp>
+      <p:sp>
+        <p:nvSpPr>
+          <p:cNvPr id="103" name="Element 103"/>
+          <p:cNvSpPr/>
+          <p:nvPr/>
+        </p:nvSpPr>
+        <p:spPr>
+          <a:xfrm>
+            <a:off x="8961120" y="2377440"/>
+            <a:ext cx="2286000" cy="457200"/>
+          </a:xfrm>
+          <a:prstGeom prst="rect">
+            <a:avLst/>
+          </a:prstGeom>
+          <a:noFill/>
+          <a:ln>
+            <a:noFill/>
+          </a:ln>
+        </p:spPr>
+        <p:txBody>
+          <a:bodyPr wrap="square" lIns="0" tIns="0" rIns="0" bIns="0" anchor="ctr">
+            <a:noAutofit/>
+          </a:bodyPr>
+          <a:lstStyle/>
+          <a:p>
+            <a:pPr algn="r"/>
+            <a:r>
+              <a:rPr lang="pl-PL" sz="1800" b="0" dirty="0">
+                <a:solidFill>
+                  <a:srgbClr val="404040"/>
+                </a:solidFill>
+                <a:latin typeface="+mn-lt"/>
+              </a:rPr>
+              <a:t>zimne</a:t>
+            </a:r>
+          </a:p>
+        </p:txBody>
+      </p:sp>
+      <p:sp>
+        <p:nvSpPr>
+          <p:cNvPr id="104" name="Element 104"/>
+          <p:cNvSpPr/>
+          <p:nvPr/>
+        </p:nvSpPr>
+        <p:spPr>
+          <a:xfrm>
+            <a:off x="6126480" y="3794760"/>
+            <a:ext cx="2286000" cy="457200"/>
+          </a:xfrm>
+          <a:prstGeom prst="rect">
+            <a:avLst/>
+          </a:prstGeom>
+          <a:noFill/>
+          <a:ln>
+            <a:noFill/>
+          </a:ln>
+        </p:spPr>
+        <p:txBody>
+          <a:bodyPr wrap="square" lIns="0" tIns="0" rIns="0" bIns="0" anchor="ctr">
+            <a:noAutofit/>
+          </a:bodyPr>
+          <a:lstStyle/>
+          <a:p>
+            <a:pPr algn="l"/>
+            <a:r>
+              <a:rPr lang="pl-PL" sz="1600" b="0" dirty="0">
+                <a:solidFill>
+                  <a:srgbClr val="8A8A8A"/>
+                </a:solidFill>
+                <a:latin typeface="+mn-lt"/>
+              </a:rPr>
+              <a:t>ok. 2700 K</a:t>
+            </a:r>
+          </a:p>
+        </p:txBody>
+      </p:sp>
+      <p:sp>
+        <p:nvSpPr>
+          <p:cNvPr id="105" name="Element 105"/>
+          <p:cNvSpPr/>
+          <p:nvPr/>
+        </p:nvSpPr>
+        <p:spPr>
+          <a:xfrm>
+            <a:off x="8961120" y="3794760"/>
+            <a:ext cx="2286000" cy="457200"/>
+          </a:xfrm>
+          <a:prstGeom prst="rect">
+            <a:avLst/>
+          </a:prstGeom>
+          <a:noFill/>
+          <a:ln>
+            <a:noFill/>
+          </a:ln>
+        </p:spPr>
+        <p:txBody>
+          <a:bodyPr wrap="square" lIns="0" tIns="0" rIns="0" bIns="0" anchor="ctr">
+            <a:noAutofit/>
+          </a:bodyPr>
+          <a:lstStyle/>
+          <a:p>
+            <a:pPr algn="r"/>
+            <a:r>
+              <a:rPr lang="pl-PL" sz="1600" b="0" dirty="0">
+                <a:solidFill>
+                  <a:srgbClr val="8A8A8A"/>
+                </a:solidFill>
+                <a:latin typeface="+mn-lt"/>
+              </a:rPr>
+              <a:t>ok. 6500 K</a:t>
+            </a:r>
+          </a:p>
+        </p:txBody>
+      </p:sp>
+      <p:sp>
+        <p:nvSpPr>
+          <p:cNvPr id="106" name="Element 106"/>
+          <p:cNvSpPr/>
+          <p:nvPr/>
+        </p:nvSpPr>
+        <p:spPr>
+          <a:xfrm>
+            <a:off x="6126480" y="4663440"/>
+            <a:ext cx="5120640" cy="457200"/>
+          </a:xfrm>
+          <a:prstGeom prst="rect">
+            <a:avLst/>
+          </a:prstGeom>
+          <a:noFill/>
+          <a:ln>
+            <a:noFill/>
+          </a:ln>
+        </p:spPr>
+        <p:txBody>
+          <a:bodyPr wrap="square" lIns="0" tIns="0" rIns="0" bIns="0" anchor="ctr">
+            <a:noAutofit/>
+          </a:bodyPr>
+          <a:lstStyle/>
+          <a:p>
+            <a:pPr algn="l"/>
+            <a:r>
+              <a:rPr lang="pl-PL" sz="1600" b="0" dirty="0">
+                <a:solidFill>
+                  <a:srgbClr val="8A8A8A"/>
+                </a:solidFill>
+                <a:latin typeface="+mn-lt"/>
+              </a:rPr>
+              <a:t>temperatura barwowa światła</a:t>
+            </a:r>
+          </a:p>
+        </p:txBody>
+      </p:sp>
     </p:spTree>
     <p:extLst>
       <p:ext uri="{BB962C8B-B14F-4D97-AF65-F5344CB8AC3E}">
@@ -18561,6 +20274,583 @@
           </a:p>
         </p:txBody>
       </p:sp>
+      <p:sp>
+        <p:nvSpPr>
+          <p:cNvPr id="101" name="Element 101"/>
+          <p:cNvSpPr/>
+          <p:nvPr/>
+        </p:nvSpPr>
+        <p:spPr>
+          <a:xfrm>
+            <a:off x="6812280" y="1645920"/>
+            <a:ext cx="3566160" cy="3566160"/>
+          </a:xfrm>
+          <a:prstGeom prst="ellipse">
+            <a:avLst/>
+          </a:prstGeom>
+          <a:noFill/>
+          <a:ln w="15875">
+            <a:solidFill>
+              <a:srgbClr val="E3B18D"/>
+            </a:solidFill>
+            <a:prstDash val="dash"/>
+          </a:ln>
+        </p:spPr>
+        <p:txBody>
+          <a:bodyPr/>
+          <a:lstStyle/>
+          <a:p>
+            <a:endParaRPr lang="pl-PL"/>
+          </a:p>
+        </p:txBody>
+      </p:sp>
+      <p:sp>
+        <p:nvSpPr>
+          <p:cNvPr id="102" name="Element 102"/>
+          <p:cNvSpPr/>
+          <p:nvPr/>
+        </p:nvSpPr>
+        <p:spPr>
+          <a:xfrm>
+            <a:off x="8138160" y="2971800"/>
+            <a:ext cx="914400" cy="914400"/>
+          </a:xfrm>
+          <a:prstGeom prst="ellipse">
+            <a:avLst/>
+          </a:prstGeom>
+          <a:solidFill>
+            <a:srgbClr val="404040"/>
+          </a:solidFill>
+          <a:ln>
+            <a:noFill/>
+          </a:ln>
+        </p:spPr>
+        <p:txBody>
+          <a:bodyPr/>
+          <a:lstStyle/>
+          <a:p>
+            <a:endParaRPr lang="pl-PL"/>
+          </a:p>
+        </p:txBody>
+      </p:sp>
+      <p:sp>
+        <p:nvSpPr>
+          <p:cNvPr id="103" name="Element 103"/>
+          <p:cNvSpPr/>
+          <p:nvPr/>
+        </p:nvSpPr>
+        <p:spPr>
+          <a:xfrm>
+            <a:off x="8138160" y="3246120"/>
+            <a:ext cx="914400" cy="365760"/>
+          </a:xfrm>
+          <a:prstGeom prst="rect">
+            <a:avLst/>
+          </a:prstGeom>
+          <a:noFill/>
+          <a:ln>
+            <a:noFill/>
+          </a:ln>
+        </p:spPr>
+        <p:txBody>
+          <a:bodyPr wrap="square" lIns="0" tIns="0" rIns="0" bIns="0" anchor="ctr">
+            <a:noAutofit/>
+          </a:bodyPr>
+          <a:lstStyle/>
+          <a:p>
+            <a:pPr algn="ctr"/>
+            <a:r>
+              <a:rPr lang="pl-PL" sz="1200" b="0" dirty="0">
+                <a:solidFill>
+                  <a:srgbClr val="FFFFFF"/>
+                </a:solidFill>
+                <a:latin typeface="+mn-lt"/>
+              </a:rPr>
+              <a:t>model</a:t>
+            </a:r>
+          </a:p>
+        </p:txBody>
+      </p:sp>
+      <p:cxnSp>
+        <p:nvCxnSpPr>
+          <p:cNvPr id="104" name="Linia 104"/>
+          <p:cNvCxnSpPr/>
+          <p:nvPr/>
+        </p:nvCxnSpPr>
+        <p:spPr>
+          <a:xfrm>
+            <a:off x="8595360" y="3886200"/>
+            <a:ext cx="0" cy="1124712"/>
+          </a:xfrm>
+          <a:prstGeom prst="line">
+            <a:avLst/>
+          </a:prstGeom>
+          <a:ln w="15875">
+            <a:solidFill>
+              <a:srgbClr val="E3B18D"/>
+            </a:solidFill>
+          </a:ln>
+        </p:spPr>
+      </p:cxnSp>
+      <p:sp>
+        <p:nvSpPr>
+          <p:cNvPr id="105" name="Element 105"/>
+          <p:cNvSpPr/>
+          <p:nvPr/>
+        </p:nvSpPr>
+        <p:spPr>
+          <a:xfrm>
+            <a:off x="8394192" y="5010912"/>
+            <a:ext cx="402336" cy="402336"/>
+          </a:xfrm>
+          <a:prstGeom prst="ellipse">
+            <a:avLst/>
+          </a:prstGeom>
+          <a:solidFill>
+            <a:srgbClr val="E3B18D"/>
+          </a:solidFill>
+          <a:ln>
+            <a:noFill/>
+          </a:ln>
+        </p:spPr>
+        <p:txBody>
+          <a:bodyPr/>
+          <a:lstStyle/>
+          <a:p>
+            <a:endParaRPr lang="pl-PL"/>
+          </a:p>
+        </p:txBody>
+      </p:sp>
+      <p:sp>
+        <p:nvSpPr>
+          <p:cNvPr id="106" name="Element 106"/>
+          <p:cNvSpPr/>
+          <p:nvPr/>
+        </p:nvSpPr>
+        <p:spPr>
+          <a:xfrm>
+            <a:off x="7863840" y="5486400"/>
+            <a:ext cx="1188720" cy="365760"/>
+          </a:xfrm>
+          <a:prstGeom prst="rect">
+            <a:avLst/>
+          </a:prstGeom>
+          <a:noFill/>
+          <a:ln>
+            <a:noFill/>
+          </a:ln>
+        </p:spPr>
+        <p:txBody>
+          <a:bodyPr wrap="square" lIns="0" tIns="0" rIns="0" bIns="0" anchor="ctr">
+            <a:noAutofit/>
+          </a:bodyPr>
+          <a:lstStyle/>
+          <a:p>
+            <a:pPr algn="ctr"/>
+            <a:r>
+              <a:rPr lang="pl-PL" sz="1600" b="0" dirty="0">
+                <a:solidFill>
+                  <a:srgbClr val="404040"/>
+                </a:solidFill>
+                <a:latin typeface="+mn-lt"/>
+              </a:rPr>
+              <a:t>Front</a:t>
+            </a:r>
+          </a:p>
+        </p:txBody>
+      </p:sp>
+      <p:cxnSp>
+        <p:nvCxnSpPr>
+          <p:cNvPr id="107" name="Linia 107"/>
+          <p:cNvCxnSpPr/>
+          <p:nvPr/>
+        </p:nvCxnSpPr>
+        <p:spPr>
+          <a:xfrm>
+            <a:off x="9052560" y="3429000"/>
+            <a:ext cx="1124712" cy="0"/>
+          </a:xfrm>
+          <a:prstGeom prst="line">
+            <a:avLst/>
+          </a:prstGeom>
+          <a:ln w="15875">
+            <a:solidFill>
+              <a:srgbClr val="E3B18D"/>
+            </a:solidFill>
+          </a:ln>
+        </p:spPr>
+      </p:cxnSp>
+      <p:sp>
+        <p:nvSpPr>
+          <p:cNvPr id="108" name="Element 108"/>
+          <p:cNvSpPr/>
+          <p:nvPr/>
+        </p:nvSpPr>
+        <p:spPr>
+          <a:xfrm>
+            <a:off x="10177272" y="3227832"/>
+            <a:ext cx="402336" cy="402336"/>
+          </a:xfrm>
+          <a:prstGeom prst="ellipse">
+            <a:avLst/>
+          </a:prstGeom>
+          <a:solidFill>
+            <a:srgbClr val="E3B18D"/>
+          </a:solidFill>
+          <a:ln>
+            <a:noFill/>
+          </a:ln>
+        </p:spPr>
+        <p:txBody>
+          <a:bodyPr/>
+          <a:lstStyle/>
+          <a:p>
+            <a:endParaRPr lang="pl-PL"/>
+          </a:p>
+        </p:txBody>
+      </p:sp>
+      <p:sp>
+        <p:nvSpPr>
+          <p:cNvPr id="109" name="Element 109"/>
+          <p:cNvSpPr/>
+          <p:nvPr/>
+        </p:nvSpPr>
+        <p:spPr>
+          <a:xfrm>
+            <a:off x="10652760" y="3246120"/>
+            <a:ext cx="1188720" cy="365760"/>
+          </a:xfrm>
+          <a:prstGeom prst="rect">
+            <a:avLst/>
+          </a:prstGeom>
+          <a:noFill/>
+          <a:ln>
+            <a:noFill/>
+          </a:ln>
+        </p:spPr>
+        <p:txBody>
+          <a:bodyPr wrap="square" lIns="0" tIns="0" rIns="0" bIns="0" anchor="ctr">
+            <a:noAutofit/>
+          </a:bodyPr>
+          <a:lstStyle/>
+          <a:p>
+            <a:pPr algn="l"/>
+            <a:r>
+              <a:rPr lang="pl-PL" sz="1600" b="0" dirty="0">
+                <a:solidFill>
+                  <a:srgbClr val="404040"/>
+                </a:solidFill>
+                <a:latin typeface="+mn-lt"/>
+              </a:rPr>
+              <a:t>Side</a:t>
+            </a:r>
+          </a:p>
+        </p:txBody>
+      </p:sp>
+      <p:cxnSp>
+        <p:nvCxnSpPr>
+          <p:cNvPr id="110" name="Linia 110"/>
+          <p:cNvCxnSpPr/>
+          <p:nvPr/>
+        </p:nvCxnSpPr>
+        <p:spPr>
+          <a:xfrm>
+            <a:off x="8595360" y="1847088"/>
+            <a:ext cx="0" cy="1124712"/>
+          </a:xfrm>
+          <a:prstGeom prst="line">
+            <a:avLst/>
+          </a:prstGeom>
+          <a:ln w="15875">
+            <a:solidFill>
+              <a:srgbClr val="E3B18D"/>
+            </a:solidFill>
+          </a:ln>
+        </p:spPr>
+      </p:cxnSp>
+      <p:sp>
+        <p:nvSpPr>
+          <p:cNvPr id="111" name="Element 111"/>
+          <p:cNvSpPr/>
+          <p:nvPr/>
+        </p:nvSpPr>
+        <p:spPr>
+          <a:xfrm>
+            <a:off x="8394192" y="1444752"/>
+            <a:ext cx="402336" cy="402336"/>
+          </a:xfrm>
+          <a:prstGeom prst="ellipse">
+            <a:avLst/>
+          </a:prstGeom>
+          <a:solidFill>
+            <a:srgbClr val="E3B18D"/>
+          </a:solidFill>
+          <a:ln>
+            <a:noFill/>
+          </a:ln>
+        </p:spPr>
+        <p:txBody>
+          <a:bodyPr/>
+          <a:lstStyle/>
+          <a:p>
+            <a:endParaRPr lang="pl-PL"/>
+          </a:p>
+        </p:txBody>
+      </p:sp>
+      <p:sp>
+        <p:nvSpPr>
+          <p:cNvPr id="112" name="Element 112"/>
+          <p:cNvSpPr/>
+          <p:nvPr/>
+        </p:nvSpPr>
+        <p:spPr>
+          <a:xfrm>
+            <a:off x="7863840" y="1143000"/>
+            <a:ext cx="1188720" cy="365760"/>
+          </a:xfrm>
+          <a:prstGeom prst="rect">
+            <a:avLst/>
+          </a:prstGeom>
+          <a:noFill/>
+          <a:ln>
+            <a:noFill/>
+          </a:ln>
+        </p:spPr>
+        <p:txBody>
+          <a:bodyPr wrap="square" lIns="0" tIns="0" rIns="0" bIns="0" anchor="ctr">
+            <a:noAutofit/>
+          </a:bodyPr>
+          <a:lstStyle/>
+          <a:p>
+            <a:pPr algn="ctr"/>
+            <a:r>
+              <a:rPr lang="pl-PL" sz="1600" b="0" dirty="0">
+                <a:solidFill>
+                  <a:srgbClr val="404040"/>
+                </a:solidFill>
+                <a:latin typeface="+mn-lt"/>
+              </a:rPr>
+              <a:t>Back</a:t>
+            </a:r>
+          </a:p>
+        </p:txBody>
+      </p:sp>
+      <p:cxnSp>
+        <p:nvCxnSpPr>
+          <p:cNvPr id="113" name="Linia 113"/>
+          <p:cNvCxnSpPr/>
+          <p:nvPr/>
+        </p:nvCxnSpPr>
+        <p:spPr>
+          <a:xfrm>
+            <a:off x="7476779" y="2310419"/>
+            <a:ext cx="795291" cy="795291"/>
+          </a:xfrm>
+          <a:prstGeom prst="line">
+            <a:avLst/>
+          </a:prstGeom>
+          <a:ln w="15875">
+            <a:solidFill>
+              <a:srgbClr val="E3B18D"/>
+            </a:solidFill>
+          </a:ln>
+        </p:spPr>
+      </p:cxnSp>
+      <p:sp>
+        <p:nvSpPr>
+          <p:cNvPr id="114" name="Element 114"/>
+          <p:cNvSpPr/>
+          <p:nvPr/>
+        </p:nvSpPr>
+        <p:spPr>
+          <a:xfrm>
+            <a:off x="7133364" y="1967004"/>
+            <a:ext cx="402336" cy="402336"/>
+          </a:xfrm>
+          <a:prstGeom prst="ellipse">
+            <a:avLst/>
+          </a:prstGeom>
+          <a:solidFill>
+            <a:srgbClr val="E3B18D"/>
+          </a:solidFill>
+          <a:ln>
+            <a:noFill/>
+          </a:ln>
+        </p:spPr>
+        <p:txBody>
+          <a:bodyPr/>
+          <a:lstStyle/>
+          <a:p>
+            <a:endParaRPr lang="pl-PL"/>
+          </a:p>
+        </p:txBody>
+      </p:sp>
+      <p:sp>
+        <p:nvSpPr>
+          <p:cNvPr id="115" name="Element 115"/>
+          <p:cNvSpPr/>
+          <p:nvPr/>
+        </p:nvSpPr>
+        <p:spPr>
+          <a:xfrm>
+            <a:off x="5871492" y="1665252"/>
+            <a:ext cx="1188720" cy="365760"/>
+          </a:xfrm>
+          <a:prstGeom prst="rect">
+            <a:avLst/>
+          </a:prstGeom>
+          <a:noFill/>
+          <a:ln>
+            <a:noFill/>
+          </a:ln>
+        </p:spPr>
+        <p:txBody>
+          <a:bodyPr wrap="square" lIns="0" tIns="0" rIns="0" bIns="0" anchor="ctr">
+            <a:noAutofit/>
+          </a:bodyPr>
+          <a:lstStyle/>
+          <a:p>
+            <a:pPr algn="r"/>
+            <a:r>
+              <a:rPr lang="pl-PL" sz="1600" b="0" dirty="0">
+                <a:solidFill>
+                  <a:srgbClr val="404040"/>
+                </a:solidFill>
+                <a:latin typeface="+mn-lt"/>
+              </a:rPr>
+              <a:t>Counter</a:t>
+            </a:r>
+          </a:p>
+        </p:txBody>
+      </p:sp>
+      <p:cxnSp>
+        <p:nvCxnSpPr>
+          <p:cNvPr id="116" name="Linia 116"/>
+          <p:cNvCxnSpPr/>
+          <p:nvPr/>
+        </p:nvCxnSpPr>
+        <p:spPr>
+          <a:xfrm flipV="1">
+            <a:off x="8918649" y="2310419"/>
+            <a:ext cx="795291" cy="795291"/>
+          </a:xfrm>
+          <a:prstGeom prst="line">
+            <a:avLst/>
+          </a:prstGeom>
+          <a:ln w="15875">
+            <a:solidFill>
+              <a:srgbClr val="E3B18D"/>
+            </a:solidFill>
+          </a:ln>
+        </p:spPr>
+      </p:cxnSp>
+      <p:sp>
+        <p:nvSpPr>
+          <p:cNvPr id="117" name="Element 117"/>
+          <p:cNvSpPr/>
+          <p:nvPr/>
+        </p:nvSpPr>
+        <p:spPr>
+          <a:xfrm>
+            <a:off x="9655020" y="1967004"/>
+            <a:ext cx="402336" cy="402336"/>
+          </a:xfrm>
+          <a:prstGeom prst="ellipse">
+            <a:avLst/>
+          </a:prstGeom>
+          <a:solidFill>
+            <a:srgbClr val="E3B18D"/>
+          </a:solidFill>
+          <a:ln>
+            <a:noFill/>
+          </a:ln>
+        </p:spPr>
+        <p:txBody>
+          <a:bodyPr/>
+          <a:lstStyle/>
+          <a:p>
+            <a:endParaRPr lang="pl-PL"/>
+          </a:p>
+        </p:txBody>
+      </p:sp>
+      <p:sp>
+        <p:nvSpPr>
+          <p:cNvPr id="118" name="Element 118"/>
+          <p:cNvSpPr/>
+          <p:nvPr/>
+        </p:nvSpPr>
+        <p:spPr>
+          <a:xfrm>
+            <a:off x="10130508" y="1665252"/>
+            <a:ext cx="1188720" cy="365760"/>
+          </a:xfrm>
+          <a:prstGeom prst="rect">
+            <a:avLst/>
+          </a:prstGeom>
+          <a:noFill/>
+          <a:ln>
+            <a:noFill/>
+          </a:ln>
+        </p:spPr>
+        <p:txBody>
+          <a:bodyPr wrap="square" lIns="0" tIns="0" rIns="0" bIns="0" anchor="ctr">
+            <a:noAutofit/>
+          </a:bodyPr>
+          <a:lstStyle/>
+          <a:p>
+            <a:pPr algn="l"/>
+            <a:r>
+              <a:rPr lang="pl-PL" sz="1600" b="0" dirty="0">
+                <a:solidFill>
+                  <a:srgbClr val="404040"/>
+                </a:solidFill>
+                <a:latin typeface="+mn-lt"/>
+              </a:rPr>
+              <a:t>Top (z góry)</a:t>
+            </a:r>
+          </a:p>
+        </p:txBody>
+      </p:sp>
+      <p:sp>
+        <p:nvSpPr>
+          <p:cNvPr id="119" name="Element 119"/>
+          <p:cNvSpPr/>
+          <p:nvPr/>
+        </p:nvSpPr>
+        <p:spPr>
+          <a:xfrm>
+            <a:off x="8229600" y="5897880"/>
+            <a:ext cx="731520" cy="411480"/>
+          </a:xfrm>
+          <a:prstGeom prst="roundRect">
+            <a:avLst/>
+          </a:prstGeom>
+          <a:noFill/>
+          <a:ln w="19050">
+            <a:solidFill>
+              <a:srgbClr val="404040"/>
+            </a:solidFill>
+          </a:ln>
+        </p:spPr>
+        <p:txBody>
+          <a:bodyPr wrap="square" lIns="0" tIns="0" rIns="0" bIns="0" anchor="ctr">
+            <a:noAutofit/>
+          </a:bodyPr>
+          <a:lstStyle/>
+          <a:p>
+            <a:pPr algn="ctr"/>
+            <a:r>
+              <a:rPr lang="pl-PL" sz="1200" b="0" dirty="0">
+                <a:solidFill>
+                  <a:srgbClr val="404040"/>
+                </a:solidFill>
+                <a:latin typeface="+mn-lt"/>
+              </a:rPr>
+              <a:t>kamera</a:t>
+            </a:r>
+          </a:p>
+        </p:txBody>
+      </p:sp>
     </p:spTree>
     <p:extLst>
       <p:ext uri="{BB962C8B-B14F-4D97-AF65-F5344CB8AC3E}">
@@ -18721,6 +21011,643 @@
               <a:t>8</a:t>
             </a:fld>
             <a:endParaRPr lang="pl-PL" noProof="0"/>
+          </a:p>
+        </p:txBody>
+      </p:sp>
+      <p:sp>
+        <p:nvSpPr>
+          <p:cNvPr id="101" name="Element 101"/>
+          <p:cNvSpPr/>
+          <p:nvPr/>
+        </p:nvSpPr>
+        <p:spPr>
+          <a:xfrm>
+            <a:off x="6108192" y="4983480"/>
+            <a:ext cx="265176" cy="137160"/>
+          </a:xfrm>
+          <a:prstGeom prst="rect">
+            <a:avLst/>
+          </a:prstGeom>
+          <a:solidFill>
+            <a:srgbClr val="E3B18D"/>
+          </a:solidFill>
+          <a:ln>
+            <a:noFill/>
+          </a:ln>
+        </p:spPr>
+        <p:txBody>
+          <a:bodyPr/>
+          <a:lstStyle/>
+          <a:p>
+            <a:endParaRPr lang="pl-PL"/>
+          </a:p>
+        </p:txBody>
+      </p:sp>
+      <p:sp>
+        <p:nvSpPr>
+          <p:cNvPr id="102" name="Element 102"/>
+          <p:cNvSpPr/>
+          <p:nvPr/>
+        </p:nvSpPr>
+        <p:spPr>
+          <a:xfrm>
+            <a:off x="6419088" y="4800600"/>
+            <a:ext cx="265176" cy="320040"/>
+          </a:xfrm>
+          <a:prstGeom prst="rect">
+            <a:avLst/>
+          </a:prstGeom>
+          <a:solidFill>
+            <a:srgbClr val="E3B18D"/>
+          </a:solidFill>
+          <a:ln>
+            <a:noFill/>
+          </a:ln>
+        </p:spPr>
+        <p:txBody>
+          <a:bodyPr/>
+          <a:lstStyle/>
+          <a:p>
+            <a:endParaRPr lang="pl-PL"/>
+          </a:p>
+        </p:txBody>
+      </p:sp>
+      <p:sp>
+        <p:nvSpPr>
+          <p:cNvPr id="103" name="Element 103"/>
+          <p:cNvSpPr/>
+          <p:nvPr/>
+        </p:nvSpPr>
+        <p:spPr>
+          <a:xfrm>
+            <a:off x="6729984" y="4480560"/>
+            <a:ext cx="265176" cy="640080"/>
+          </a:xfrm>
+          <a:prstGeom prst="rect">
+            <a:avLst/>
+          </a:prstGeom>
+          <a:solidFill>
+            <a:srgbClr val="E3B18D"/>
+          </a:solidFill>
+          <a:ln>
+            <a:noFill/>
+          </a:ln>
+        </p:spPr>
+        <p:txBody>
+          <a:bodyPr/>
+          <a:lstStyle/>
+          <a:p>
+            <a:endParaRPr lang="pl-PL"/>
+          </a:p>
+        </p:txBody>
+      </p:sp>
+      <p:sp>
+        <p:nvSpPr>
+          <p:cNvPr id="104" name="Element 104"/>
+          <p:cNvSpPr/>
+          <p:nvPr/>
+        </p:nvSpPr>
+        <p:spPr>
+          <a:xfrm>
+            <a:off x="7040880" y="4023360"/>
+            <a:ext cx="265176" cy="1097280"/>
+          </a:xfrm>
+          <a:prstGeom prst="rect">
+            <a:avLst/>
+          </a:prstGeom>
+          <a:solidFill>
+            <a:srgbClr val="E3B18D"/>
+          </a:solidFill>
+          <a:ln>
+            <a:noFill/>
+          </a:ln>
+        </p:spPr>
+        <p:txBody>
+          <a:bodyPr/>
+          <a:lstStyle/>
+          <a:p>
+            <a:endParaRPr lang="pl-PL"/>
+          </a:p>
+        </p:txBody>
+      </p:sp>
+      <p:sp>
+        <p:nvSpPr>
+          <p:cNvPr id="105" name="Element 105"/>
+          <p:cNvSpPr/>
+          <p:nvPr/>
+        </p:nvSpPr>
+        <p:spPr>
+          <a:xfrm>
+            <a:off x="7351776" y="3474720"/>
+            <a:ext cx="265176" cy="1645920"/>
+          </a:xfrm>
+          <a:prstGeom prst="rect">
+            <a:avLst/>
+          </a:prstGeom>
+          <a:solidFill>
+            <a:srgbClr val="E3B18D"/>
+          </a:solidFill>
+          <a:ln>
+            <a:noFill/>
+          </a:ln>
+        </p:spPr>
+        <p:txBody>
+          <a:bodyPr/>
+          <a:lstStyle/>
+          <a:p>
+            <a:endParaRPr lang="pl-PL"/>
+          </a:p>
+        </p:txBody>
+      </p:sp>
+      <p:sp>
+        <p:nvSpPr>
+          <p:cNvPr id="106" name="Element 106"/>
+          <p:cNvSpPr/>
+          <p:nvPr/>
+        </p:nvSpPr>
+        <p:spPr>
+          <a:xfrm>
+            <a:off x="7662672" y="3017520"/>
+            <a:ext cx="265176" cy="2103120"/>
+          </a:xfrm>
+          <a:prstGeom prst="rect">
+            <a:avLst/>
+          </a:prstGeom>
+          <a:solidFill>
+            <a:srgbClr val="E3B18D"/>
+          </a:solidFill>
+          <a:ln>
+            <a:noFill/>
+          </a:ln>
+        </p:spPr>
+        <p:txBody>
+          <a:bodyPr/>
+          <a:lstStyle/>
+          <a:p>
+            <a:endParaRPr lang="pl-PL"/>
+          </a:p>
+        </p:txBody>
+      </p:sp>
+      <p:sp>
+        <p:nvSpPr>
+          <p:cNvPr id="107" name="Element 107"/>
+          <p:cNvSpPr/>
+          <p:nvPr/>
+        </p:nvSpPr>
+        <p:spPr>
+          <a:xfrm>
+            <a:off x="7973568" y="2651760"/>
+            <a:ext cx="265176" cy="2468880"/>
+          </a:xfrm>
+          <a:prstGeom prst="rect">
+            <a:avLst/>
+          </a:prstGeom>
+          <a:solidFill>
+            <a:srgbClr val="E3B18D"/>
+          </a:solidFill>
+          <a:ln>
+            <a:noFill/>
+          </a:ln>
+        </p:spPr>
+        <p:txBody>
+          <a:bodyPr/>
+          <a:lstStyle/>
+          <a:p>
+            <a:endParaRPr lang="pl-PL"/>
+          </a:p>
+        </p:txBody>
+      </p:sp>
+      <p:sp>
+        <p:nvSpPr>
+          <p:cNvPr id="108" name="Element 108"/>
+          <p:cNvSpPr/>
+          <p:nvPr/>
+        </p:nvSpPr>
+        <p:spPr>
+          <a:xfrm>
+            <a:off x="8284464" y="2743200"/>
+            <a:ext cx="265176" cy="2377440"/>
+          </a:xfrm>
+          <a:prstGeom prst="rect">
+            <a:avLst/>
+          </a:prstGeom>
+          <a:solidFill>
+            <a:srgbClr val="E3B18D"/>
+          </a:solidFill>
+          <a:ln>
+            <a:noFill/>
+          </a:ln>
+        </p:spPr>
+        <p:txBody>
+          <a:bodyPr/>
+          <a:lstStyle/>
+          <a:p>
+            <a:endParaRPr lang="pl-PL"/>
+          </a:p>
+        </p:txBody>
+      </p:sp>
+      <p:sp>
+        <p:nvSpPr>
+          <p:cNvPr id="109" name="Element 109"/>
+          <p:cNvSpPr/>
+          <p:nvPr/>
+        </p:nvSpPr>
+        <p:spPr>
+          <a:xfrm>
+            <a:off x="8595360" y="3108960"/>
+            <a:ext cx="265176" cy="2011680"/>
+          </a:xfrm>
+          <a:prstGeom prst="rect">
+            <a:avLst/>
+          </a:prstGeom>
+          <a:solidFill>
+            <a:srgbClr val="E3B18D"/>
+          </a:solidFill>
+          <a:ln>
+            <a:noFill/>
+          </a:ln>
+        </p:spPr>
+        <p:txBody>
+          <a:bodyPr/>
+          <a:lstStyle/>
+          <a:p>
+            <a:endParaRPr lang="pl-PL"/>
+          </a:p>
+        </p:txBody>
+      </p:sp>
+      <p:sp>
+        <p:nvSpPr>
+          <p:cNvPr id="110" name="Element 110"/>
+          <p:cNvSpPr/>
+          <p:nvPr/>
+        </p:nvSpPr>
+        <p:spPr>
+          <a:xfrm>
+            <a:off x="8906256" y="3566160"/>
+            <a:ext cx="265176" cy="1554480"/>
+          </a:xfrm>
+          <a:prstGeom prst="rect">
+            <a:avLst/>
+          </a:prstGeom>
+          <a:solidFill>
+            <a:srgbClr val="E3B18D"/>
+          </a:solidFill>
+          <a:ln>
+            <a:noFill/>
+          </a:ln>
+        </p:spPr>
+        <p:txBody>
+          <a:bodyPr/>
+          <a:lstStyle/>
+          <a:p>
+            <a:endParaRPr lang="pl-PL"/>
+          </a:p>
+        </p:txBody>
+      </p:sp>
+      <p:sp>
+        <p:nvSpPr>
+          <p:cNvPr id="111" name="Element 111"/>
+          <p:cNvSpPr/>
+          <p:nvPr/>
+        </p:nvSpPr>
+        <p:spPr>
+          <a:xfrm>
+            <a:off x="9217152" y="4023360"/>
+            <a:ext cx="265176" cy="1097280"/>
+          </a:xfrm>
+          <a:prstGeom prst="rect">
+            <a:avLst/>
+          </a:prstGeom>
+          <a:solidFill>
+            <a:srgbClr val="E3B18D"/>
+          </a:solidFill>
+          <a:ln>
+            <a:noFill/>
+          </a:ln>
+        </p:spPr>
+        <p:txBody>
+          <a:bodyPr/>
+          <a:lstStyle/>
+          <a:p>
+            <a:endParaRPr lang="pl-PL"/>
+          </a:p>
+        </p:txBody>
+      </p:sp>
+      <p:sp>
+        <p:nvSpPr>
+          <p:cNvPr id="112" name="Element 112"/>
+          <p:cNvSpPr/>
+          <p:nvPr/>
+        </p:nvSpPr>
+        <p:spPr>
+          <a:xfrm>
+            <a:off x="9528048" y="4389120"/>
+            <a:ext cx="265176" cy="731520"/>
+          </a:xfrm>
+          <a:prstGeom prst="rect">
+            <a:avLst/>
+          </a:prstGeom>
+          <a:solidFill>
+            <a:srgbClr val="E3B18D"/>
+          </a:solidFill>
+          <a:ln>
+            <a:noFill/>
+          </a:ln>
+        </p:spPr>
+        <p:txBody>
+          <a:bodyPr/>
+          <a:lstStyle/>
+          <a:p>
+            <a:endParaRPr lang="pl-PL"/>
+          </a:p>
+        </p:txBody>
+      </p:sp>
+      <p:sp>
+        <p:nvSpPr>
+          <p:cNvPr id="113" name="Element 113"/>
+          <p:cNvSpPr/>
+          <p:nvPr/>
+        </p:nvSpPr>
+        <p:spPr>
+          <a:xfrm>
+            <a:off x="9838944" y="4663440"/>
+            <a:ext cx="265176" cy="457200"/>
+          </a:xfrm>
+          <a:prstGeom prst="rect">
+            <a:avLst/>
+          </a:prstGeom>
+          <a:solidFill>
+            <a:srgbClr val="E3B18D"/>
+          </a:solidFill>
+          <a:ln>
+            <a:noFill/>
+          </a:ln>
+        </p:spPr>
+        <p:txBody>
+          <a:bodyPr/>
+          <a:lstStyle/>
+          <a:p>
+            <a:endParaRPr lang="pl-PL"/>
+          </a:p>
+        </p:txBody>
+      </p:sp>
+      <p:sp>
+        <p:nvSpPr>
+          <p:cNvPr id="114" name="Element 114"/>
+          <p:cNvSpPr/>
+          <p:nvPr/>
+        </p:nvSpPr>
+        <p:spPr>
+          <a:xfrm>
+            <a:off x="10149840" y="4800600"/>
+            <a:ext cx="265176" cy="320040"/>
+          </a:xfrm>
+          <a:prstGeom prst="rect">
+            <a:avLst/>
+          </a:prstGeom>
+          <a:solidFill>
+            <a:srgbClr val="E3B18D"/>
+          </a:solidFill>
+          <a:ln>
+            <a:noFill/>
+          </a:ln>
+        </p:spPr>
+        <p:txBody>
+          <a:bodyPr/>
+          <a:lstStyle/>
+          <a:p>
+            <a:endParaRPr lang="pl-PL"/>
+          </a:p>
+        </p:txBody>
+      </p:sp>
+      <p:sp>
+        <p:nvSpPr>
+          <p:cNvPr id="115" name="Element 115"/>
+          <p:cNvSpPr/>
+          <p:nvPr/>
+        </p:nvSpPr>
+        <p:spPr>
+          <a:xfrm>
+            <a:off x="10460736" y="4892040"/>
+            <a:ext cx="265176" cy="228600"/>
+          </a:xfrm>
+          <a:prstGeom prst="rect">
+            <a:avLst/>
+          </a:prstGeom>
+          <a:solidFill>
+            <a:srgbClr val="E3B18D"/>
+          </a:solidFill>
+          <a:ln>
+            <a:noFill/>
+          </a:ln>
+        </p:spPr>
+        <p:txBody>
+          <a:bodyPr/>
+          <a:lstStyle/>
+          <a:p>
+            <a:endParaRPr lang="pl-PL"/>
+          </a:p>
+        </p:txBody>
+      </p:sp>
+      <p:sp>
+        <p:nvSpPr>
+          <p:cNvPr id="116" name="Element 116"/>
+          <p:cNvSpPr/>
+          <p:nvPr/>
+        </p:nvSpPr>
+        <p:spPr>
+          <a:xfrm>
+            <a:off x="10771632" y="5010912"/>
+            <a:ext cx="265176" cy="109728"/>
+          </a:xfrm>
+          <a:prstGeom prst="rect">
+            <a:avLst/>
+          </a:prstGeom>
+          <a:solidFill>
+            <a:srgbClr val="E3B18D"/>
+          </a:solidFill>
+          <a:ln>
+            <a:noFill/>
+          </a:ln>
+        </p:spPr>
+        <p:txBody>
+          <a:bodyPr/>
+          <a:lstStyle/>
+          <a:p>
+            <a:endParaRPr lang="pl-PL"/>
+          </a:p>
+        </p:txBody>
+      </p:sp>
+      <p:cxnSp>
+        <p:nvCxnSpPr>
+          <p:cNvPr id="117" name="Linia 117"/>
+          <p:cNvCxnSpPr/>
+          <p:nvPr/>
+        </p:nvCxnSpPr>
+        <p:spPr>
+          <a:xfrm>
+            <a:off x="6016752" y="5120640"/>
+            <a:ext cx="5111496" cy="0"/>
+          </a:xfrm>
+          <a:prstGeom prst="line">
+            <a:avLst/>
+          </a:prstGeom>
+          <a:ln w="19050">
+            <a:solidFill>
+              <a:srgbClr val="404040"/>
+            </a:solidFill>
+          </a:ln>
+        </p:spPr>
+      </p:cxnSp>
+      <p:sp>
+        <p:nvSpPr>
+          <p:cNvPr id="118" name="Element 118"/>
+          <p:cNvSpPr/>
+          <p:nvPr/>
+        </p:nvSpPr>
+        <p:spPr>
+          <a:xfrm>
+            <a:off x="6108192" y="5257800"/>
+            <a:ext cx="1371600" cy="365760"/>
+          </a:xfrm>
+          <a:prstGeom prst="rect">
+            <a:avLst/>
+          </a:prstGeom>
+          <a:noFill/>
+          <a:ln>
+            <a:noFill/>
+          </a:ln>
+        </p:spPr>
+        <p:txBody>
+          <a:bodyPr wrap="square" lIns="0" tIns="0" rIns="0" bIns="0" anchor="ctr">
+            <a:noAutofit/>
+          </a:bodyPr>
+          <a:lstStyle/>
+          <a:p>
+            <a:pPr algn="l"/>
+            <a:r>
+              <a:rPr lang="pl-PL" sz="1600" b="0" dirty="0">
+                <a:solidFill>
+                  <a:srgbClr val="8A8A8A"/>
+                </a:solidFill>
+                <a:latin typeface="+mn-lt"/>
+              </a:rPr>
+              <a:t>cienie</a:t>
+            </a:r>
+          </a:p>
+        </p:txBody>
+      </p:sp>
+      <p:sp>
+        <p:nvSpPr>
+          <p:cNvPr id="119" name="Element 119"/>
+          <p:cNvSpPr/>
+          <p:nvPr/>
+        </p:nvSpPr>
+        <p:spPr>
+          <a:xfrm>
+            <a:off x="7863840" y="5257800"/>
+            <a:ext cx="1463040" cy="365760"/>
+          </a:xfrm>
+          <a:prstGeom prst="rect">
+            <a:avLst/>
+          </a:prstGeom>
+          <a:noFill/>
+          <a:ln>
+            <a:noFill/>
+          </a:ln>
+        </p:spPr>
+        <p:txBody>
+          <a:bodyPr wrap="square" lIns="0" tIns="0" rIns="0" bIns="0" anchor="ctr">
+            <a:noAutofit/>
+          </a:bodyPr>
+          <a:lstStyle/>
+          <a:p>
+            <a:pPr algn="ctr"/>
+            <a:r>
+              <a:rPr lang="pl-PL" sz="1600" b="0" dirty="0">
+                <a:solidFill>
+                  <a:srgbClr val="8A8A8A"/>
+                </a:solidFill>
+                <a:latin typeface="+mn-lt"/>
+              </a:rPr>
+              <a:t>półtony</a:t>
+            </a:r>
+          </a:p>
+        </p:txBody>
+      </p:sp>
+      <p:sp>
+        <p:nvSpPr>
+          <p:cNvPr id="120" name="Element 120"/>
+          <p:cNvSpPr/>
+          <p:nvPr/>
+        </p:nvSpPr>
+        <p:spPr>
+          <a:xfrm>
+            <a:off x="9710928" y="5257800"/>
+            <a:ext cx="1371600" cy="365760"/>
+          </a:xfrm>
+          <a:prstGeom prst="rect">
+            <a:avLst/>
+          </a:prstGeom>
+          <a:noFill/>
+          <a:ln>
+            <a:noFill/>
+          </a:ln>
+        </p:spPr>
+        <p:txBody>
+          <a:bodyPr wrap="square" lIns="0" tIns="0" rIns="0" bIns="0" anchor="ctr">
+            <a:noAutofit/>
+          </a:bodyPr>
+          <a:lstStyle/>
+          <a:p>
+            <a:pPr algn="r"/>
+            <a:r>
+              <a:rPr lang="pl-PL" sz="1600" b="0" dirty="0">
+                <a:solidFill>
+                  <a:srgbClr val="8A8A8A"/>
+                </a:solidFill>
+                <a:latin typeface="+mn-lt"/>
+              </a:rPr>
+              <a:t>światła</a:t>
+            </a:r>
+          </a:p>
+        </p:txBody>
+      </p:sp>
+      <p:sp>
+        <p:nvSpPr>
+          <p:cNvPr id="121" name="Element 121"/>
+          <p:cNvSpPr/>
+          <p:nvPr/>
+        </p:nvSpPr>
+        <p:spPr>
+          <a:xfrm>
+            <a:off x="6108192" y="1463040"/>
+            <a:ext cx="4974336" cy="457200"/>
+          </a:xfrm>
+          <a:prstGeom prst="rect">
+            <a:avLst/>
+          </a:prstGeom>
+          <a:noFill/>
+          <a:ln>
+            <a:noFill/>
+          </a:ln>
+        </p:spPr>
+        <p:txBody>
+          <a:bodyPr wrap="square" lIns="0" tIns="0" rIns="0" bIns="0" anchor="ctr">
+            <a:noAutofit/>
+          </a:bodyPr>
+          <a:lstStyle/>
+          <a:p>
+            <a:pPr algn="l"/>
+            <a:r>
+              <a:rPr lang="pl-PL" sz="1800" b="1" dirty="0">
+                <a:solidFill>
+                  <a:srgbClr val="404040"/>
+                </a:solidFill>
+                <a:latin typeface="+mn-lt"/>
+              </a:rPr>
+              <a:t>histogram</a:t>
+            </a:r>
           </a:p>
         </p:txBody>
       </p:sp>

</xml_diff>